<commit_message>
slides: 本人の編集版を更新 (10-03 12:37)
</commit_message>
<xml_diff>
--- a/slides/2026-10-03_研究進捗報告_claude.pptx
+++ b/slides/2026-10-03_研究進捗報告_claude.pptx
@@ -190,7 +190,7 @@
   <pc:docChgLst>
     <pc:chgData name="202304239" userId="ab1adf7a-b8eb-4038-b404-de23e20d8a3a" providerId="ADAL" clId="{6C0E59ED-D716-49AF-B2FA-B94E7B8E5A8C}"/>
     <pc:docChg chg="custSel modSld">
-      <pc:chgData name="202304239" userId="ab1adf7a-b8eb-4038-b404-de23e20d8a3a" providerId="ADAL" clId="{6C0E59ED-D716-49AF-B2FA-B94E7B8E5A8C}" dt="2026-10-03T03:37:00.554" v="38" actId="20577"/>
+      <pc:chgData name="202304239" userId="ab1adf7a-b8eb-4038-b404-de23e20d8a3a" providerId="ADAL" clId="{6C0E59ED-D716-49AF-B2FA-B94E7B8E5A8C}" dt="2026-10-03T03:37:06.765" v="53" actId="20577"/>
       <pc:docMkLst>
         <pc:docMk/>
       </pc:docMkLst>
@@ -255,13 +255,13 @@
         </pc:picChg>
       </pc:sldChg>
       <pc:sldChg chg="modSp mod">
-        <pc:chgData name="202304239" userId="ab1adf7a-b8eb-4038-b404-de23e20d8a3a" providerId="ADAL" clId="{6C0E59ED-D716-49AF-B2FA-B94E7B8E5A8C}" dt="2026-10-03T03:37:00.554" v="38" actId="20577"/>
+        <pc:chgData name="202304239" userId="ab1adf7a-b8eb-4038-b404-de23e20d8a3a" providerId="ADAL" clId="{6C0E59ED-D716-49AF-B2FA-B94E7B8E5A8C}" dt="2026-10-03T03:37:06.765" v="53" actId="20577"/>
         <pc:sldMkLst>
           <pc:docMk/>
           <pc:sldMk cId="0" sldId="308"/>
         </pc:sldMkLst>
         <pc:spChg chg="mod">
-          <ac:chgData name="202304239" userId="ab1adf7a-b8eb-4038-b404-de23e20d8a3a" providerId="ADAL" clId="{6C0E59ED-D716-49AF-B2FA-B94E7B8E5A8C}" dt="2026-10-03T03:37:00.554" v="38" actId="20577"/>
+          <ac:chgData name="202304239" userId="ab1adf7a-b8eb-4038-b404-de23e20d8a3a" providerId="ADAL" clId="{6C0E59ED-D716-49AF-B2FA-B94E7B8E5A8C}" dt="2026-10-03T03:37:06.765" v="53" actId="20577"/>
           <ac:spMkLst>
             <pc:docMk/>
             <pc:sldMk cId="0" sldId="308"/>
@@ -8655,12 +8655,9 @@
             <a:endParaRPr lang="en-US" sz="2600"/>
           </a:p>
           <a:p>
-            <a:pPr marL="0" indent="0">
-              <a:buNone/>
-            </a:pPr>
             <a:r>
               <a:rPr lang="en-US" altLang="ja-JP" sz="2400"/>
-              <a:t>	ln L = Σ_i [ C_obs,i ln C_exp,i − C_exp,i ]</a:t>
+              <a:t>ln L = Σ_i [ C_obs,i ln C_exp,i − C_exp,i ]</a:t>
             </a:r>
           </a:p>
           <a:p>

</xml_diff>

<commit_message>
slides: 本人の編集版を更新 (10-03 13:14)
</commit_message>
<xml_diff>
--- a/slides/2026-10-03_研究進捗報告_claude.pptx
+++ b/slides/2026-10-03_研究進捗報告_claude.pptx
@@ -5,55 +5,55 @@
     <p:sldMasterId id="2147483648" r:id="rId1"/>
   </p:sldMasterIdLst>
   <p:notesMasterIdLst>
-    <p:notesMasterId r:id="rId53"/>
+    <p:notesMasterId r:id="rId48"/>
   </p:notesMasterIdLst>
   <p:sldIdLst>
     <p:sldId id="256" r:id="rId2"/>
     <p:sldId id="257" r:id="rId3"/>
     <p:sldId id="258" r:id="rId4"/>
     <p:sldId id="259" r:id="rId5"/>
-    <p:sldId id="312" r:id="rId60"/>
-    <p:sldId id="307" r:id="rId12"/>
-    <p:sldId id="308" r:id="rId13"/>
-    <p:sldId id="294" r:id="rId14"/>
-    <p:sldId id="261" r:id="rId15"/>
-    <p:sldId id="262" r:id="rId16"/>
-    <p:sldId id="295" r:id="rId17"/>
-    <p:sldId id="296" r:id="rId18"/>
-    <p:sldId id="297" r:id="rId19"/>
-    <p:sldId id="298" r:id="rId20"/>
-    <p:sldId id="309" r:id="rId21"/>
-    <p:sldId id="299" r:id="rId22"/>
-    <p:sldId id="300" r:id="rId23"/>
-    <p:sldId id="263" r:id="rId24"/>
-    <p:sldId id="264" r:id="rId25"/>
-    <p:sldId id="310" r:id="rId26"/>
-    <p:sldId id="311" r:id="rId27"/>
-    <p:sldId id="265" r:id="rId28"/>
-    <p:sldId id="266" r:id="rId29"/>
-    <p:sldId id="267" r:id="rId30"/>
-    <p:sldId id="268" r:id="rId31"/>
-    <p:sldId id="269" r:id="rId32"/>
-    <p:sldId id="271" r:id="rId33"/>
-    <p:sldId id="272" r:id="rId34"/>
-    <p:sldId id="273" r:id="rId35"/>
-    <p:sldId id="274" r:id="rId36"/>
-    <p:sldId id="275" r:id="rId37"/>
-    <p:sldId id="276" r:id="rId38"/>
-    <p:sldId id="277" r:id="rId39"/>
-    <p:sldId id="278" r:id="rId40"/>
-    <p:sldId id="279" r:id="rId41"/>
-    <p:sldId id="280" r:id="rId42"/>
-    <p:sldId id="281" r:id="rId43"/>
-    <p:sldId id="282" r:id="rId44"/>
-    <p:sldId id="283" r:id="rId45"/>
-    <p:sldId id="284" r:id="rId46"/>
-    <p:sldId id="285" r:id="rId47"/>
-    <p:sldId id="286" r:id="rId48"/>
-    <p:sldId id="287" r:id="rId49"/>
-    <p:sldId id="288" r:id="rId50"/>
-    <p:sldId id="289" r:id="rId51"/>
-    <p:sldId id="290" r:id="rId52"/>
+    <p:sldId id="312" r:id="rId6"/>
+    <p:sldId id="307" r:id="rId7"/>
+    <p:sldId id="308" r:id="rId8"/>
+    <p:sldId id="294" r:id="rId9"/>
+    <p:sldId id="261" r:id="rId10"/>
+    <p:sldId id="262" r:id="rId11"/>
+    <p:sldId id="295" r:id="rId12"/>
+    <p:sldId id="296" r:id="rId13"/>
+    <p:sldId id="297" r:id="rId14"/>
+    <p:sldId id="298" r:id="rId15"/>
+    <p:sldId id="309" r:id="rId16"/>
+    <p:sldId id="299" r:id="rId17"/>
+    <p:sldId id="300" r:id="rId18"/>
+    <p:sldId id="263" r:id="rId19"/>
+    <p:sldId id="264" r:id="rId20"/>
+    <p:sldId id="310" r:id="rId21"/>
+    <p:sldId id="311" r:id="rId22"/>
+    <p:sldId id="265" r:id="rId23"/>
+    <p:sldId id="266" r:id="rId24"/>
+    <p:sldId id="267" r:id="rId25"/>
+    <p:sldId id="268" r:id="rId26"/>
+    <p:sldId id="269" r:id="rId27"/>
+    <p:sldId id="271" r:id="rId28"/>
+    <p:sldId id="272" r:id="rId29"/>
+    <p:sldId id="273" r:id="rId30"/>
+    <p:sldId id="274" r:id="rId31"/>
+    <p:sldId id="275" r:id="rId32"/>
+    <p:sldId id="276" r:id="rId33"/>
+    <p:sldId id="277" r:id="rId34"/>
+    <p:sldId id="278" r:id="rId35"/>
+    <p:sldId id="279" r:id="rId36"/>
+    <p:sldId id="280" r:id="rId37"/>
+    <p:sldId id="281" r:id="rId38"/>
+    <p:sldId id="282" r:id="rId39"/>
+    <p:sldId id="283" r:id="rId40"/>
+    <p:sldId id="284" r:id="rId41"/>
+    <p:sldId id="285" r:id="rId42"/>
+    <p:sldId id="286" r:id="rId43"/>
+    <p:sldId id="287" r:id="rId44"/>
+    <p:sldId id="288" r:id="rId45"/>
+    <p:sldId id="289" r:id="rId46"/>
+    <p:sldId id="290" r:id="rId47"/>
   </p:sldIdLst>
   <p:sldSz cx="12192000" cy="6858000"/>
   <p:notesSz cx="6858000" cy="9144000"/>
@@ -184,7 +184,7 @@
   <pc:docChgLst>
     <pc:chgData name="202304239" userId="ab1adf7a-b8eb-4038-b404-de23e20d8a3a" providerId="ADAL" clId="{6C0E59ED-D716-49AF-B2FA-B94E7B8E5A8C}"/>
     <pc:docChg chg="custSel delSld modSld">
-      <pc:chgData name="202304239" userId="ab1adf7a-b8eb-4038-b404-de23e20d8a3a" providerId="ADAL" clId="{6C0E59ED-D716-49AF-B2FA-B94E7B8E5A8C}" dt="2026-10-03T03:37:35.283" v="54" actId="47"/>
+      <pc:chgData name="202304239" userId="ab1adf7a-b8eb-4038-b404-de23e20d8a3a" providerId="ADAL" clId="{6C0E59ED-D716-49AF-B2FA-B94E7B8E5A8C}" dt="2026-10-03T04:13:39.011" v="59" actId="27614"/>
       <pc:docMkLst>
         <pc:docMk/>
       </pc:docMkLst>
@@ -245,6 +245,21 @@
             <pc:docMk/>
             <pc:sldMk cId="0" sldId="260"/>
             <ac:picMk id="6" creationId="{00000000-0000-0000-0000-000000000000}"/>
+          </ac:picMkLst>
+        </pc:picChg>
+      </pc:sldChg>
+      <pc:sldChg chg="addSp modSp mod">
+        <pc:chgData name="202304239" userId="ab1adf7a-b8eb-4038-b404-de23e20d8a3a" providerId="ADAL" clId="{6C0E59ED-D716-49AF-B2FA-B94E7B8E5A8C}" dt="2026-10-03T04:13:39.011" v="59" actId="27614"/>
+        <pc:sldMkLst>
+          <pc:docMk/>
+          <pc:sldMk cId="0" sldId="295"/>
+        </pc:sldMkLst>
+        <pc:picChg chg="add mod">
+          <ac:chgData name="202304239" userId="ab1adf7a-b8eb-4038-b404-de23e20d8a3a" providerId="ADAL" clId="{6C0E59ED-D716-49AF-B2FA-B94E7B8E5A8C}" dt="2026-10-03T04:13:39.011" v="59" actId="27614"/>
+          <ac:picMkLst>
+            <pc:docMk/>
+            <pc:sldMk cId="0" sldId="295"/>
+            <ac:picMk id="5" creationId="{960CE5B3-4BC1-0B00-D670-CAC2F1397BD5}"/>
           </ac:picMkLst>
         </pc:picChg>
       </pc:sldChg>
@@ -661,19 +676,7 @@
           <a:bodyPr/>
           <a:lstStyle/>
           <a:p>
-            <a:r>
-              <a:t>対消滅: 暗黒物質の粒子 2 個がぶつかって消え、そのエネルギーがガンマ線などになる。粒子が 2 個要るので、明るさは密度の 2 乗に比例する。</a:t>
-            </a:r>
-          </a:p>
-          <a:p>
-            <a:r>
-              <a:t>Totani (2025) の信号は、WIMP なら質量 0.5–0.8 TeV に相当する。銀河中心 GeV 超過 (GCE、35–65 GeV の WIMP) とは別の信号。</a:t>
-            </a:r>
-          </a:p>
-          <a:p>
-            <a:r>
-              <a:t>σ (シグマ) は「偶然ではこれくらい起きにくい」という目安。5σ で約 350 万分の 1。</a:t>
-            </a:r>
+            <a:endParaRPr/>
           </a:p>
         </p:txBody>
       </p:sp>
@@ -742,22 +745,22 @@
           <a:lstStyle/>
           <a:p>
             <a:r>
-              <a:t>NFW: シミュレーションで得られる暗黒物質ハローの典型的な密度の形。中心付近では距離に反比例、外側では距離の 3 乗に反比例して薄くなる。</a:t>
-            </a:r>
-          </a:p>
-          <a:p>
-            <a:r>
-              <a:t>形はエネルギーで変わらない (どのエネルギーでも同じ地図)。明るさ (倍率) だけを各エネルギーで決める。だから「どのエネルギーでハローが必要か」が有意度のスペクトルになる。</a:t>
-            </a:r>
-          </a:p>
-          <a:p>
-            <a:r>
-              <a:t>ICS と同じく、なめらかで中心に向かって明るい。違いは、ハローのほうが中心に強く集まっていること。</a:t>
-            </a:r>
-          </a:p>
-          <a:p>
-            <a:r>
-              <a:t>右の地図: 20.8 GeV の型紙 (倍率は掛けていない。形だけを見る図)。cloud_reports/2026-10-02_plot_templates.py で作成。</a:t>
+              <a:t>MCMC (マルコフ連鎖モンテカルロ): 「今いる点の近くに一歩動いてみて、尤度が上がれば進む、下がっても確率的に進む」を繰り返す。長く歩くと、歩いた場所の分布が事後分布になる。</a:t>
+            </a:r>
+          </a:p>
+          <a:p>
+            <a:r>
+              <a:t>事前分布は一様 (倍率の符号の制約と、広い範囲の制限だけ)。</a:t>
+            </a:r>
+          </a:p>
+          <a:p>
+            <a:r>
+              <a:t>emcee は、複数の歩行者が互いの位置を使って次の一歩を決める方式 (affine-invariant ensemble sampler)。</a:t>
+            </a:r>
+          </a:p>
+          <a:p>
+            <a:r>
+              <a:t>自己相関時間 τ: 何歩離れたら前の位置を「忘れる」か。50τ 以上の長さは emcee の推奨。</a:t>
             </a:r>
           </a:p>
         </p:txBody>
@@ -827,12 +830,17 @@
           <a:lstStyle/>
           <a:p>
             <a:r>
-              <a:t>この後の尤度・有意度・MCMC のスライドは、全部「係数 9 個の決め方」の説明。難しい言葉が出てきたら、このスライドに戻って「今どの行の話か」を確認する。</a:t>
-            </a:r>
-          </a:p>
-          <a:p>
-            <a:r>
-              <a:t>型紙 = 前の 7 枚で見た地図。係数 = その地図を何倍して足すか。</a:t>
+              <a:t>このスライドが「対応表」。この後のスライドは全部この言葉で説明する。</a:t>
+            </a:r>
+          </a:p>
+          <a:p>
+            <a:r>
+              <a:t>9 次元の山は紙に描けない。だから地図全体を調べるのではなく、歩いて足あとを残し、足あとから山の形を知る。</a:t>
+            </a:r>
+          </a:p>
+          <a:p>
+            <a:r>
+              <a:t>スクショ候補: 点数 (高さ) を計算する関数 log_probability (658〜663 行)。コードは code/mcmc_fit_all_bins.py (10/3 にローカルで修正を当てた今のファイルの行番号。コミット 880fbdb)。</a:t>
             </a:r>
           </a:p>
         </p:txBody>
@@ -902,27 +910,27 @@
           <a:lstStyle/>
           <a:p>
             <a:r>
-              <a:t>たとえ: 霧で何も見えない山の上で、一番高い場所を探したい。手元には高度計 (尤度) しかない。</a:t>
-            </a:r>
-          </a:p>
-          <a:p>
-            <a:r>
-              <a:t>歩く人 (MCMC) は、一歩ずつ足を出して高度計を見る。上りなら必ずその方向へ進み、下りでもたまに進む。下りにも進むのは、山頂で止まらずに山の広がり (どこまでが十分高いか) も知るため。</a:t>
-            </a:r>
-          </a:p>
-          <a:p>
-            <a:r>
-              <a:t>歩き終わったら、記録の中で一番高かった地点が最良の倍率、よく歩き回った範囲の幅が誤差になる。</a:t>
-            </a:r>
-          </a:p>
-          <a:p>
-            <a:r>
-              <a:t>ここでの「山」は 9 次元 (倍率が 9 個)。紙に描けないので、歩いて調べるしかない。</a:t>
-            </a:r>
-          </a:p>
-          <a:p>
-            <a:r>
-              <a:t>Totani (2025) §2.2: 最良値と統計誤差を、尤度を MCMC で最大化して求める。本研究も同じ (10/2 に揃えた)。</a:t>
+              <a:t>ベイズの定理の読み方: 「データを見る前の考え (π: どこに入ってよいか)」に「データの当てはまり (L: 高度計)」を掛けると「データを見た後の考え (高さ)」になる。</a:t>
+            </a:r>
+          </a:p>
+          <a:p>
+            <a:r>
+              <a:t>今回の π は一様: 入ってよい範囲 (ガス・ICS などは 0 以上、全部 |f| ≤ 10⁶) なら同じ値、外なら 0。だから高さの形は高度計の読み (尤度) と同じになる。</a:t>
+            </a:r>
+          </a:p>
+          <a:p>
+            <a:r>
+              <a:t>P(D) は「海抜何メートルから測るか」の基準のようなもの。2 地点の高さを比べるときは、どちらにも同じ基準が入っているので割り算で消える。MCMC は比べることしかしないので、P(D) を計算しなくてよい。</a:t>
+            </a:r>
+          </a:p>
+          <a:p>
+            <a:r>
+              <a:t>対数にするのは、数が大きすぎたり小さすぎたりしてコンピュータで扱えなくなるのを防ぐため。</a:t>
+            </a:r>
+          </a:p>
+          <a:p>
+            <a:r>
+              <a:t>スクショ候補: log_prior (635〜649 行、立ち入り禁止のチェック)、log_likelihood (652〜655 行、高度計)、log_probability (658〜663 行、両方を足す)。コードは code/mcmc_fit_all_bins.py (10/3 にローカルで修正を当てた今のファイルの行番号。コミット 880fbdb)。</a:t>
             </a:r>
           </a:p>
         </p:txBody>
@@ -992,22 +1000,22 @@
           <a:lstStyle/>
           <a:p>
             <a:r>
-              <a:t>「なし」は「あり」の特別な場合 (ハローの倍率 = 0) なので、入れ子のモデル。入れ子なら Δln L ≥ 0。</a:t>
-            </a:r>
-          </a:p>
-          <a:p>
-            <a:r>
-              <a:t>Wilks の定理: 帰無仮説 (ハローなし) が正しいとき、2Δln L は自由度 1 の χ² 分布。だから √(2Δln L) が「標準正規分布で何σ」に対応する。</a:t>
-            </a:r>
-          </a:p>
-          <a:p>
-            <a:r>
-              <a:t>定理の前提: データが多い (漸近的)、モデルが正しい、など。モデル (型紙) が間違っていると成り立たない。</a:t>
-            </a:r>
-          </a:p>
-          <a:p>
-            <a:r>
-              <a:t>Totani との関係: Totani (2025) Fig. 9 はハローあり・なしの ln L の差 (Δln L) を示しており、本文の 13–19σ はそれを σ = √(2Δln L) で σ に直した値。Totani は「Wilks の定理」という言葉は書いていないが、この換算はガンマ線天文学で標準 (2Δln L は TS = test statistic と呼ばれ、EGRET の解析 Mattox et al. 1996, ApJ 461, 396 から使われている)。本研究は Totani と同じ換算を使っている。</a:t>
+              <a:t>例: 今いる場所の高さが 100、足を出した先の高さが 80 なら r = 0.8。0〜1 の乱数を引いて 0.8 より小さければ (80% の確率で) 移る。高さが 10 なら r = 0.1 で、10% しか移らない。だから、低い場所にはめったに行かず、高い場所に長くいる。</a:t>
+            </a:r>
+          </a:p>
+          <a:p>
+            <a:r>
+              <a:t>長く歩くと「各場所にいた時間の割合」が「その場所の高さ」に比例するようになる (詳細つり合い)。だから足あとのヒストグラムが山の形 (事後分布) になる。</a:t>
+            </a:r>
+          </a:p>
+          <a:p>
+            <a:r>
+              <a:t>移らなかったときも今の場所をもう一度記録するのが大事。そうしないと、高い場所にとどまった回数が数えられない。</a:t>
+            </a:r>
+          </a:p>
+          <a:p>
+            <a:r>
+              <a:t>スクショ候補: 歩かせる部分 sampler.run_mcmc (882〜883 行)。メトロポリスの判定そのものは emcee の中にある。コードは code/mcmc_fit_all_bins.py (10/3 にローカルで修正を当てた今のファイルの行番号。コミット 880fbdb)。</a:t>
             </a:r>
           </a:p>
         </p:txBody>
@@ -1077,22 +1085,22 @@
           <a:lstStyle/>
           <a:p>
             <a:r>
-              <a:t>MCMC (マルコフ連鎖モンテカルロ): 「今いる点の近くに一歩動いてみて、尤度が上がれば進む、下がっても確率的に進む」を繰り返す。長く歩くと、歩いた場所の分布が事後分布になる。</a:t>
-            </a:r>
-          </a:p>
-          <a:p>
-            <a:r>
-              <a:t>事前分布は一様 (倍率の符号の制約と、広い範囲の制限だけ)。</a:t>
-            </a:r>
-          </a:p>
-          <a:p>
-            <a:r>
-              <a:t>emcee は、複数の歩行者が互いの位置を使って次の一歩を決める方式 (affine-invariant ensemble sampler)。</a:t>
-            </a:r>
-          </a:p>
-          <a:p>
-            <a:r>
-              <a:t>自己相関時間 τ: 何歩離れたら前の位置を「忘れる」か。50τ 以上の長さは emcee の推奨。</a:t>
+              <a:t>実データではない、説明用のおもちゃの例。倍率が 1 個だけの山 (1 次元) を、平均 1.48・幅 0.075 の形だと仮定して 3000 歩歩かせた。</a:t>
+            </a:r>
+          </a:p>
+          <a:p>
+            <a:r>
+              <a:t>わざと山から離れた 1.2 から出発させたので、最初はふもとから登っていく。この登っている途中 (最初の 200 歩) は山の形と関係ないので捨てる (バーンイン)。</a:t>
+            </a:r>
+          </a:p>
+          <a:p>
+            <a:r>
+              <a:t>そのあとは山の上を行ったり来たりしている。足あとのヒストグラム (右の灰色) が、本当の山の形 (点線) と重なっている = 足あとから山の形が分かる。</a:t>
+            </a:r>
+          </a:p>
+          <a:p>
+            <a:r>
+              <a:t>図は slides/figs/plot_mcmc_toy.py で作った (コメント付き)。</a:t>
             </a:r>
           </a:p>
         </p:txBody>
@@ -1162,17 +1170,32 @@
           <a:lstStyle/>
           <a:p>
             <a:r>
-              <a:t>このスライドが「対応表」。この後のスライドは全部この言葉で説明する。</a:t>
-            </a:r>
-          </a:p>
-          <a:p>
-            <a:r>
-              <a:t>9 次元の山は紙に描けない。だから地図全体を調べるのではなく、歩いて足あとを残し、足あとから山の形を知る。</a:t>
-            </a:r>
-          </a:p>
-          <a:p>
-            <a:r>
-              <a:t>スクショ候補: 点数 (高さ) を計算する関数 log_probability (658〜663 行)。コードは code/mcmc_fit_all_bins.py (10/3 にローカルで修正を当てた今のファイルの行番号。コミット 880fbdb)。</a:t>
+              <a:t>どの歩き方でも、正しく長く歩けば足あとの分布は同じ山の形 (事後分布) になる。違うのは、歩く速さ (効率) と、どんな山が得意か。</a:t>
+            </a:r>
+          </a:p>
+          <a:p>
+            <a:r>
+              <a:t>ギブス法: 9 個の倍率のうち 1 個だけを動かし、残り 8 個は止めておく。これを順番にくり返す。</a:t>
+            </a:r>
+          </a:p>
+          <a:p>
+            <a:r>
+              <a:t>ハミルトニアン MC (HMC): 山の傾き (尤度の微分) を使って、遠くまで一気に動く。パラメータが多いときに強い。</a:t>
+            </a:r>
+          </a:p>
+          <a:p>
+            <a:r>
+              <a:t>焼きなまし法: 金属をゆっくり冷やす「焼きなまし」が名前の由来。最初は下りにもよく進み、だんだん進みにくくして、最後は頂上で止まる。最良値を探す道具で、誤差は出ない。</a:t>
+            </a:r>
+          </a:p>
+          <a:p>
+            <a:r>
+              <a:t>歩けているかの確認 (歩き方の種類ではない): 受理率 (足を出したうち、実際に移った割合。emcee では 0.2〜0.5 くらいが目安。今回の 20.8 GeV は 0.42)、自己相関時間 τ (何歩で前の場所を忘れるか)。</a:t>
+            </a:r>
+          </a:p>
+          <a:p>
+            <a:r>
+              <a:t>emcee: Foreman-Mackey et al. (2013) の Python ライブラリ。中身は Goodman &amp; Weare (2010) のアンサンブル法 (ストレッチ移動)。歩く人数・歩数・捨てる歩数は Totani の論文に書かれていないので、本研究で決めた (32 人・6000 歩・最初の 2000 歩を捨てる)。</a:t>
             </a:r>
           </a:p>
         </p:txBody>
@@ -1242,27 +1265,22 @@
           <a:lstStyle/>
           <a:p>
             <a:r>
-              <a:t>ベイズの定理の読み方: 「データを見る前の考え (π: どこに入ってよいか)」に「データの当てはまり (L: 高度計)」を掛けると「データを見た後の考え (高さ)」になる。</a:t>
-            </a:r>
-          </a:p>
-          <a:p>
-            <a:r>
-              <a:t>今回の π は一様: 入ってよい範囲 (ガス・ICS などは 0 以上、全部 |f| ≤ 10⁶) なら同じ値、外なら 0。だから高さの形は高度計の読み (尤度) と同じになる。</a:t>
-            </a:r>
-          </a:p>
-          <a:p>
-            <a:r>
-              <a:t>P(D) は「海抜何メートルから測るか」の基準のようなもの。2 地点の高さを比べるときは、どちらにも同じ基準が入っているので割り算で消える。MCMC は比べることしかしないので、P(D) を計算しなくてよい。</a:t>
-            </a:r>
-          </a:p>
-          <a:p>
-            <a:r>
-              <a:t>対数にするのは、数が大きすぎたり小さすぎたりしてコンピュータで扱えなくなるのを防ぐため。</a:t>
-            </a:r>
-          </a:p>
-          <a:p>
-            <a:r>
-              <a:t>スクショ候補: log_prior (635〜649 行、立ち入り禁止のチェック)、log_likelihood (652〜655 行、高度計)、log_probability (658〜663 行、両方を足す)。コードは code/mcmc_fit_all_bins.py (10/3 にローカルで修正を当てた今のファイルの行番号。コミット 880fbdb)。</a:t>
+              <a:t>細長い山: 仲間たちの散らばり方自体が「山が細長い方向」を表している。仲間のいる方向に沿って一歩を出すので、細長い山でも効率よく歩ける。</a:t>
+            </a:r>
+          </a:p>
+          <a:p>
+            <a:r>
+              <a:t>Z⁸ の 8 は「倍率の数 9 − 1」。線の上で伸び縮みさせた分、足を出せる場所の広さが変わるので、それを補正する。Z の範囲 1/2〜2 は emcee の決まった値 (a = 2)。</a:t>
+            </a:r>
+          </a:p>
+          <a:p>
+            <a:r>
+              <a:t>Totani と同じ初期値: 点源・GALPROP (ガス・ICS) = 1 倍、等方 = E²dN/dE 1e-4 相当、Loop I・バブル・ハロー = 0 (Totani §2.3)。</a:t>
+            </a:r>
+          </a:p>
+          <a:p>
+            <a:r>
+              <a:t>スクショ候補: 出発点を決める行 (871〜875 行)、32 人で歩かせる emcee.EnsembleSampler (882 行)。コードは code/mcmc_fit_all_bins.py (10/3 にローカルで修正を当てた今のファイルの行番号。コミット 880fbdb)。</a:t>
             </a:r>
           </a:p>
         </p:txBody>
@@ -1332,22 +1350,37 @@
           <a:lstStyle/>
           <a:p>
             <a:r>
-              <a:t>例: 今いる場所の高さが 100、足を出した先の高さが 80 なら r = 0.8。0〜1 の乱数を引いて 0.8 より小さければ (80% の確率で) 移る。高さが 10 なら r = 0.1 で、10% しか移らない。だから、低い場所にはめったに行かず、高い場所に長くいる。</a:t>
-            </a:r>
-          </a:p>
-          <a:p>
-            <a:r>
-              <a:t>長く歩くと「各場所にいた時間の割合」が「その場所の高さ」に比例するようになる (詳細つり合い)。だから足あとのヒストグラムが山の形 (事後分布) になる。</a:t>
-            </a:r>
-          </a:p>
-          <a:p>
-            <a:r>
-              <a:t>移らなかったときも今の場所をもう一度記録するのが大事。そうしないと、高い場所にとどまった回数が数えられない。</a:t>
-            </a:r>
-          </a:p>
-          <a:p>
-            <a:r>
-              <a:t>スクショ候補: 歩かせる部分 sampler.run_mcmc (882〜883 行)。メトロポリスの判定そのものは emcee の中にある。コードは code/mcmc_fit_all_bins.py (10/3 にローカルで修正を当てた今のファイルの行番号。コミット 880fbdb)。</a:t>
+              <a:t>ハローなしの山: ハローの倍率を 0 に固定した 8 次元の山。ハローありの山 (9 次元) より低いか同じ。2 つの頂上の高さの差が Δln L。</a:t>
+            </a:r>
+          </a:p>
+          <a:p>
+            <a:r>
+              <a:t>頂上に届いているかの確認: 坂を登る方法 (勾配法) で頂上を求めて、一番高い足あととの差を調べた。13 ビンすべてで ln L の差 0.6 以下、有意度の差 0.28σ 以下。確認のためだけで、結果には使っていない。</a:t>
+            </a:r>
+          </a:p>
+          <a:p>
+            <a:r>
+              <a:t>長さの目安: 自己相関時間 τ (何歩離れたら前の場所を忘れるか) の 50 倍以上が推奨。20.8 GeV で τ ≈ 650 歩なので 3 万歩以上が理想だが、6000 歩。</a:t>
+            </a:r>
+          </a:p>
+          <a:p>
+            <a:r>
+              <a:t>数字は本人 PC で、Totani と同じやり方で出した値 (10/3、results/mcmc_allbins_gasICS_v20t/)。</a:t>
+            </a:r>
+          </a:p>
+          <a:p>
+            <a:r>
+              <a:t>スクショ候補: 一番高い足あとを探す行 (884〜886 行)、有意度 (924〜925 行)、誤差の 16〜84% (941 行)。コードは code/mcmc_fit_all_bins.py (10/3 にローカルで修正を当てた今のファイルの行番号。コミット 880fbdb)。</a:t>
+            </a:r>
+          </a:p>
+          <a:p>
+            <a:r>
+              <a:t>なぜ最初を捨てるか: 出発点は Totani と同じ初期値で、山のふもとにある。最初のうちは頂上へ登っている途中なので、その足あとは「山の形」を表していない。だから誤差の計算からは外す (バーンイン)。一番高い足あと (最良値) は、捨てた分も含めて全部の中から探している。</a:t>
+            </a:r>
+          </a:p>
+          <a:p>
+            <a:r>
+              <a:t>捨てる歩数は本研究で決めた値 (Totani の論文には書かれていない)。最初は 400 歩だったが、歩く人数 (20/32/64)・乱数の種 (3 通り)・歩数 (6000/20000) を変えて確かめたところ、400 歩では誤差の上端が乱数の種によって 1.59〜1.89 とぶれたので、2000 歩に変えた (2000 歩ではどれも 1.56〜1.57。この確認は型紙の作り方が少し違う確認用の計算で、本番の 2000 歩の誤差は 1.40〜1.56)。最良値 1.48 と有意度 19.0σ (本人 PC) は捨てる歩数によらず同じ。</a:t>
             </a:r>
           </a:p>
         </p:txBody>
@@ -1417,22 +1450,22 @@
           <a:lstStyle/>
           <a:p>
             <a:r>
-              <a:t>実データではない、説明用のおもちゃの例。倍率が 1 個だけの山 (1 次元) を、平均 1.48・幅 0.075 の形だと仮定して 3000 歩歩かせた。</a:t>
-            </a:r>
-          </a:p>
-          <a:p>
-            <a:r>
-              <a:t>わざと山から離れた 1.2 から出発させたので、最初はふもとから登っていく。この登っている途中 (最初の 200 歩) は山の形と関係ないので捨てる (バーンイン)。</a:t>
-            </a:r>
-          </a:p>
-          <a:p>
-            <a:r>
-              <a:t>そのあとは山の上を行ったり来たりしている。足あとのヒストグラム (右の灰色) が、本当の山の形 (点線) と重なっている = 足あとから山の形が分かる。</a:t>
-            </a:r>
-          </a:p>
-          <a:p>
-            <a:r>
-              <a:t>図は slides/figs/plot_mcmc_toy.py で作った (コメント付き)。</a:t>
+              <a:t>青が本研究 (10/3、本人 PC で Totani と同じやり方 = MCMC で最良値。results/mcmc_allbins_gasICS_v20t/)、赤が Totani Fig. 9。</a:t>
+            </a:r>
+          </a:p>
+          <a:p>
+            <a:r>
+              <a:t>緑は青を 1.26 で割ったもの。1.26 = 何も無い空 23 か所で同じ解析をしたときの σ のばらつき (本当は 1 になるはず)。薄い緑の帯は 1.26 の 95% 区間 (1.14–1.39) で割った範囲。20.8 GeV で 15.1σ (13.7–16.7σ)。</a:t>
+            </a:r>
+          </a:p>
+          <a:p>
+            <a:r>
+              <a:t>注意: 赤 (Totani) は較正していない名目の値。緑と赤が近いのは、定義の違う値どうしの比較なので、「Totani の値が正しく較正されている」という意味ではない。同じ定義で比べるのは青と赤。</a:t>
+            </a:r>
+          </a:p>
+          <a:p>
+            <a:r>
+              <a:t>較正の仮定: 19σ のような大きな値でも同じ 1.26 倍かは確かめていない。</a:t>
             </a:r>
           </a:p>
         </p:txBody>
@@ -1502,32 +1535,18 @@
           <a:lstStyle/>
           <a:p>
             <a:r>
-              <a:t>どの歩き方でも、正しく長く歩けば足あとの分布は同じ山の形 (事後分布) になる。違うのは、歩く速さ (効率) と、どんな山が得意か。</a:t>
-            </a:r>
-          </a:p>
-          <a:p>
-            <a:r>
-              <a:t>ギブス法: 9 個の倍率のうち 1 個だけを動かし、残り 8 個は止めておく。これを順番にくり返す。</a:t>
-            </a:r>
-          </a:p>
-          <a:p>
-            <a:r>
-              <a:t>ハミルトニアン MC (HMC): 山の傾き (尤度の微分) を使って、遠くまで一気に動く。パラメータが多いときに強い。</a:t>
-            </a:r>
-          </a:p>
-          <a:p>
-            <a:r>
-              <a:t>焼きなまし法: 金属をゆっくり冷やす「焼きなまし」が名前の由来。最初は下りにもよく進み、だんだん進みにくくして、最後は頂上で止まる。最良値を探す道具で、誤差は出ない。</a:t>
-            </a:r>
-          </a:p>
-          <a:p>
-            <a:r>
-              <a:t>歩けているかの確認 (歩き方の種類ではない): 受理率 (足を出したうち、実際に移った割合。emcee では 0.2〜0.5 くらいが目安。今回の 20.8 GeV は 0.42)、自己相関時間 τ (何歩で前の場所を忘れるか)。</a:t>
-            </a:r>
-          </a:p>
-          <a:p>
-            <a:r>
-              <a:t>emcee: Foreman-Mackey et al. (2013) の Python ライブラリ。中身は Goodman &amp; Weare (2010) のアンサンブル法 (ストレッチ移動)。歩く人数・歩数・捨てる歩数は Totani の論文に書かれていないので、本研究で決めた (32 人・6000 歩・最初の 2000 歩を捨てる)。</a:t>
+              <a:t>縮退: 2 つの成分の形が似ていて、どちらに光を割り振っても同じくらい合ってしまう状態。</a:t>
+            </a:r>
+          </a:p>
+          <a:p>
+            <a:r>
+              <a:t>たとえ: 部屋に電球 (ICS) がついていて、もう 1 つの光 (ハロー) を探している。写真では 2 つの光の形がほとんど同じなので、余った明るさが本当にもう 1 つの光なのか、電球が少し明るいだけなのか見分けにくい。</a:t>
+            </a:r>
+          </a:p>
+          <a:p>
+            <a:r>
+              <a:t>図: 20.8 GeV の型紙そのもの (倍率は掛けていない)。横軸は銀河面からの角度、縦軸は明るさ (|b| = 25° を 1 にそろえた。経度は ROI 全体で平均)。2 本の線がほぼ重なる = 緯度方向の暗くなり方が同じ。作図 /home/arsei/slidework/make_lat_profile.py。
+(前の図: ICS の倍率。ハローなしでは全エネルギーで約 1.4〜1.6 倍でほぼ平ら。ハローを入れると、ハローが効くビンでだけへこむ。slides/figs/fig_ics_norm_totani.png)</a:t>
             </a:r>
           </a:p>
         </p:txBody>
@@ -1597,17 +1616,17 @@
           <a:lstStyle/>
           <a:p>
             <a:r>
-              <a:t>Totani (2025) §2.1 と同じ選び方。画素は 0.125°。</a:t>
-            </a:r>
-          </a:p>
-          <a:p>
-            <a:r>
-              <a:t>本研究のデータは 780 週のうち 778 週 (2 週分が欠けている)。</a:t>
-            </a:r>
-          </a:p>
-          <a:p>
-            <a:r>
-              <a:t>銀河面を除くのは、ガスや点源が多すぎて背景の誤差が大きいため。</a:t>
+              <a:t>対消滅: 暗黒物質の粒子 2 個がぶつかって消え、そのエネルギーがガンマ線などになる。粒子が 2 個要るので、明るさは密度の 2 乗に比例する。</a:t>
+            </a:r>
+          </a:p>
+          <a:p>
+            <a:r>
+              <a:t>Totani (2025) の信号は、WIMP なら質量 0.5–0.8 TeV に相当する。銀河中心 GeV 超過 (GCE、35–65 GeV の WIMP) とは別の信号。</a:t>
+            </a:r>
+          </a:p>
+          <a:p>
+            <a:r>
+              <a:t>σ (シグマ) は「偶然ではこれくらい起きにくい」という目安。5σ で約 350 万分の 1。</a:t>
             </a:r>
           </a:p>
         </p:txBody>
@@ -1677,22 +1696,32 @@
           <a:lstStyle/>
           <a:p>
             <a:r>
-              <a:t>細長い山: 仲間たちの散らばり方自体が「山が細長い方向」を表している。仲間のいる方向に沿って一歩を出すので、細長い山でも効率よく歩ける。</a:t>
-            </a:r>
-          </a:p>
-          <a:p>
-            <a:r>
-              <a:t>Z⁸ の 8 は「倍率の数 9 − 1」。線の上で伸び縮みさせた分、足を出せる場所の広さが変わるので、それを補正する。Z の範囲 1/2〜2 は emcee の決まった値 (a = 2)。</a:t>
-            </a:r>
-          </a:p>
-          <a:p>
-            <a:r>
-              <a:t>Totani と同じ初期値: 点源・GALPROP (ガス・ICS) = 1 倍、等方 = E²dN/dE 1e-4 相当、Loop I・バブル・ハロー = 0 (Totani §2.3)。</a:t>
-            </a:r>
-          </a:p>
-          <a:p>
-            <a:r>
-              <a:t>スクショ候補: 出発点を決める行 (871〜875 行)、32 人で歩かせる emcee.EnsembleSampler (882 行)。コードは code/mcmc_fit_all_bins.py (10/3 にローカルで修正を当てた今のファイルの行番号。コミット 880fbdb)。</a:t>
+              <a:t>図は 20.8 GeV の型紙そのもの (倍率は掛けていない)。ICS は GALPROP (galdef SLZ6R30T150C2)、ハローは NFW (Via Lactea II)。</a:t>
+            </a:r>
+          </a:p>
+          <a:p>
+            <a:r>
+              <a:t>縦方向 (経度を全部平均、|b| 25°→55°): ハロー 2.70 倍、ICS 2.60 倍暗くなる → ほぼ同じ。</a:t>
+            </a:r>
+          </a:p>
+          <a:p>
+            <a:r>
+              <a:t>横方向 (|b| = 20〜40° の帯、|l| 0°→40°): ハロー 2.67 倍、ICS 1.18 倍 → ここが違う。</a:t>
+            </a:r>
+          </a:p>
+          <a:p>
+            <a:r>
+              <a:t>ICS が横に広いのは、星の光と電子が銀河の円盤 (横に広い) に沿って多いため。ハローは丸い玉なので、どの向きにも同じように中心へ集まる。</a:t>
+            </a:r>
+          </a:p>
+          <a:p>
+            <a:r>
+              <a:t>太陽は銀河中心から 8 kpc 離れているので、どちらも空いっぱいに広がったぼんやりした光に見える。</a:t>
+            </a:r>
+          </a:p>
+          <a:p>
+            <a:r>
+              <a:t>作図: /home/arsei/slidework/make_profiles.py (2026-10-03、ローカル)</a:t>
             </a:r>
           </a:p>
         </p:txBody>
@@ -1762,37 +1791,32 @@
           <a:lstStyle/>
           <a:p>
             <a:r>
-              <a:t>ハローなしの山: ハローの倍率を 0 に固定した 8 次元の山。ハローありの山 (9 次元) より低いか同じ。2 つの頂上の高さの差が Δln L。</a:t>
-            </a:r>
-          </a:p>
-          <a:p>
-            <a:r>
-              <a:t>頂上に届いているかの確認: 坂を登る方法 (勾配法) で頂上を求めて、一番高い足あととの差を調べた。13 ビンすべてで ln L の差 0.6 以下、有意度の差 0.28σ 以下。確認のためだけで、結果には使っていない。</a:t>
-            </a:r>
-          </a:p>
-          <a:p>
-            <a:r>
-              <a:t>長さの目安: 自己相関時間 τ (何歩離れたら前の場所を忘れるか) の 50 倍以上が推奨。20.8 GeV で τ ≈ 650 歩なので 3 万歩以上が理想だが、6000 歩。</a:t>
-            </a:r>
-          </a:p>
-          <a:p>
-            <a:r>
-              <a:t>数字は本人 PC で、Totani と同じやり方で出した値 (10/3、results/mcmc_allbins_gasICS_v20t/)。</a:t>
-            </a:r>
-          </a:p>
-          <a:p>
-            <a:r>
-              <a:t>スクショ候補: 一番高い足あとを探す行 (884〜886 行)、有意度 (924〜925 行)、誤差の 16〜84% (941 行)。コードは code/mcmc_fit_all_bins.py (10/3 にローカルで修正を当てた今のファイルの行番号。コミット 880fbdb)。</a:t>
-            </a:r>
-          </a:p>
-          <a:p>
-            <a:r>
-              <a:t>なぜ最初を捨てるか: 出発点は Totani と同じ初期値で、山のふもとにある。最初のうちは頂上へ登っている途中なので、その足あとは「山の形」を表していない。だから誤差の計算からは外す (バーンイン)。一番高い足あと (最良値) は、捨てた分も含めて全部の中から探している。</a:t>
-            </a:r>
-          </a:p>
-          <a:p>
-            <a:r>
-              <a:t>捨てる歩数は本研究で決めた値 (Totani の論文には書かれていない)。最初は 400 歩だったが、歩く人数 (20/32/64)・乱数の種 (3 通り)・歩数 (6000/20000) を変えて確かめたところ、400 歩では誤差の上端が乱数の種によって 1.59〜1.89 とぶれたので、2000 歩に変えた (2000 歩ではどれも 1.56〜1.57。この確認は型紙の作り方が少し違う確認用の計算で、本番の 2000 歩の誤差は 1.40〜1.56)。最良値 1.48 と有意度 19.0σ (本人 PC) は捨てる歩数によらず同じ。</a:t>
+              <a:t>等方背景の倍率 (本研究 / Totani): 20 GeV 付近で約 0.4 倍、一番低いエネルギー (1.5 GeV) では v20 で約 1/200。</a:t>
+            </a:r>
+          </a:p>
+          <a:p>
+            <a:r>
+              <a:t>Loop I の近い殻: 太陽が殻の壁の中 (半径 62〜81 pc、太陽から中心まで 78 pc) にいるので、ROI 全体を覆い、等方背景と数学的に区別できない (.dev/TOTANI_SPEC.md 3.7a)。</a:t>
+            </a:r>
+          </a:p>
+          <a:p>
+            <a:r>
+              <a:t>空の上の方だけで計算 (|b| ≥ 30°, 40°): 1.5 GeV の等方背景の倍率が 19 倍、55 倍に戻る。Totani 比 0.005 → 0.27 (2026-07-31、MCMC_BMIN)。</a:t>
+            </a:r>
+          </a:p>
+          <a:p>
+            <a:r>
+              <a:t>低いエネルギーでは、GALPROP の出力のスペクトルが Totani と違う (1.5 GeV で 0.56 倍) ことも効いている。</a:t>
+            </a:r>
+          </a:p>
+          <a:p>
+            <a:r>
+              <a:t>全成分の合計の明るさは Totani とほぼ同じ (0.96 倍)、ハロー単独も 1.16 倍。</a:t>
+            </a:r>
+          </a:p>
+          <a:p>
+            <a:r>
+              <a:t>図: 20.8 GeV の型紙、|b| = 20〜40° の帯での横方向の明るさ。作図 /home/arsei/slidework/make_profiles.py</a:t>
             </a:r>
           </a:p>
         </p:txBody>
@@ -1862,22 +1886,12 @@
           <a:lstStyle/>
           <a:p>
             <a:r>
-              <a:t>青が本研究 (10/3、本人 PC で Totani と同じやり方 = MCMC で最良値。results/mcmc_allbins_gasICS_v20t/)、赤が Totani Fig. 9。</a:t>
-            </a:r>
-          </a:p>
-          <a:p>
-            <a:r>
-              <a:t>緑は青を 1.26 で割ったもの。1.26 = 何も無い空 23 か所で同じ解析をしたときの σ のばらつき (本当は 1 になるはず)。薄い緑の帯は 1.26 の 95% 区間 (1.14–1.39) で割った範囲。20.8 GeV で 15.1σ (13.7–16.7σ)。</a:t>
-            </a:r>
-          </a:p>
-          <a:p>
-            <a:r>
-              <a:t>注意: 赤 (Totani) は較正していない名目の値。緑と赤が近いのは、定義の違う値どうしの比較なので、「Totani の値が正しく較正されている」という意味ではない。同じ定義で比べるのは青と赤。</a:t>
-            </a:r>
-          </a:p>
-          <a:p>
-            <a:r>
-              <a:t>較正の仮定: 19σ のような大きな値でも同じ 1.26 倍かは確かめていない。</a:t>
+              <a:t>① フェルミバブル = 銀河中心の上下に広がる、ガンマ線で明るい泡状の構造。その矩形 |l| &lt; 22°, 10° &lt; |b| &lt; 55° を当てはめから外した。</a:t>
+            </a:r>
+          </a:p>
+          <a:p>
+            <a:r>
+              <a:t>② 何も無い空 23 か所で同じ解析をした (2026-07-31)。</a:t>
             </a:r>
           </a:p>
         </p:txBody>
@@ -1947,18 +1961,27 @@
           <a:lstStyle/>
           <a:p>
             <a:r>
-              <a:t>縮退: 2 つの成分の形が似ていて、どちらに光を割り振っても同じくらい合ってしまう状態。</a:t>
-            </a:r>
-          </a:p>
-          <a:p>
-            <a:r>
-              <a:t>たとえ: 部屋に電球 (ICS) がついていて、もう 1 つの光 (ハロー) を探している。写真では 2 つの光の形がほとんど同じなので、余った明るさが本当にもう 1 つの光なのか、電球が少し明るいだけなのか見分けにくい。</a:t>
-            </a:r>
-          </a:p>
-          <a:p>
-            <a:r>
-              <a:t>図: 20.8 GeV の型紙そのもの (倍率は掛けていない)。横軸は銀河面からの角度、縦軸は明るさ (|b| = 25° を 1 にそろえた。経度は ROI 全体で平均)。2 本の線がほぼ重なる = 緯度方向の暗くなり方が同じ。作図 /home/arsei/slidework/make_lat_profile.py。
-(前の図: ICS の倍率。ハローなしでは全エネルギーで約 1.4〜1.6 倍でほぼ平ら。ハローを入れると、ハローが効くビンでだけへこむ。slides/figs/fig_ics_norm_totani.png)</a:t>
+              <a:t>フィッシャー情報: 尤度の山の鋭さ (2 階微分)。山が鋭いほどパラメータがよく決まる。</a:t>
+            </a:r>
+          </a:p>
+          <a:p>
+            <a:r>
+              <a:t>「ハローだけの手がかり」= 他の成分と区別できる部分の情報 (フィッシャー行列のシューア補行列)。有意度は、おおよそ「倍率の推定値 ÷ その誤差」で、誤差は情報の平方根に反比例する。</a:t>
+            </a:r>
+          </a:p>
+          <a:p>
+            <a:r>
+              <a:t>予測 6.4σ と実測 5.0σ の残りの差は、バブル外でハローの倍率が 0.77 倍と低いことで説明できる (予測 6.4σ は 10/1 の v20r で計算したフィッシャー情報から。実測と倍率は 10/3 本人 PC、Totani 方式)。この内外の差は約 1.5σ で、意味のある差ではない。</a:t>
+            </a:r>
+          </a:p>
+          <a:p>
+            <a:r>
+              <a:t>対照: 同じ形の矩形を経度方向に ±20°, ±30°, ±38° ずらして外すと 14.6〜16.4σ (Totani と同じやり方)。</a:t>
+            </a:r>
+          </a:p>
+          <a:p>
+            <a:r>
+              <a:t>たとえ: 写真の真ん中を隠すと自信が下がるが、それは見分けるヒントが真ん中に集まっていたから。</a:t>
             </a:r>
           </a:p>
         </p:txBody>
@@ -2028,32 +2051,22 @@
           <a:lstStyle/>
           <a:p>
             <a:r>
-              <a:t>図は 20.8 GeV の型紙そのもの (倍率は掛けていない)。ICS は GALPROP (galdef SLZ6R30T150C2)、ハローは NFW (Via Lactea II)。</a:t>
-            </a:r>
-          </a:p>
-          <a:p>
-            <a:r>
-              <a:t>縦方向 (経度を全部平均、|b| 25°→55°): ハロー 2.70 倍、ICS 2.60 倍暗くなる → ほぼ同じ。</a:t>
-            </a:r>
-          </a:p>
-          <a:p>
-            <a:r>
-              <a:t>横方向 (|b| = 20〜40° の帯、|l| 0°→40°): ハロー 2.67 倍、ICS 1.18 倍 → ここが違う。</a:t>
-            </a:r>
-          </a:p>
-          <a:p>
-            <a:r>
-              <a:t>ICS が横に広いのは、星の光と電子が銀河の円盤 (横に広い) に沿って多いため。ハローは丸い玉なので、どの向きにも同じように中心へ集まる。</a:t>
-            </a:r>
-          </a:p>
-          <a:p>
-            <a:r>
-              <a:t>太陽は銀河中心から 8 kpc 離れているので、どちらも空いっぱいに広がったぼんやりした光に見える。</a:t>
-            </a:r>
-          </a:p>
-          <a:p>
-            <a:r>
-              <a:t>作図: /home/arsei/slidework/make_profiles.py (2026-10-03、ローカル)</a:t>
+              <a:t>全体の明るさのずれ (ICS が GALPROP の 1.6 倍、など) は倍率が吸収するのでハローにはならない。ハローに化けるには「銀河中心寄りだけ明るい」という形のずれが必要。</a:t>
+            </a:r>
+          </a:p>
+          <a:p>
+            <a:r>
+              <a:t>等方近似: GALPROP の設定が IC_anisotropic = 0。Moskalenko &amp; Strong (2000) Fig. 6 では、非等方にすると 10 GeV 付近で 1.1〜1.3 倍、銀河中心の上より外側のほうが大きい。</a:t>
+            </a:r>
+          </a:p>
+          <a:p>
+            <a:r>
+              <a:t>3 分割 = 星の光・ちり・宇宙背景の光、の 3 種類の光を電子がはね上げたもの。19.0σ と 17.8σ は本人 PC で、Totani と同じやり方で出した値 (10/3、results/mcmc_allbins_gasICS_v20t_icssplit/)。Totani §3.4.4 の同種の確認とも同じ結論。</a:t>
+            </a:r>
+          </a:p>
+          <a:p>
+            <a:r>
+              <a:t>残る可能性: GALPROP の ICS の「空間の形」が、銀河中心寄りで 2.3 倍ずれている場合。今の道具では確かめられない。</a:t>
             </a:r>
           </a:p>
         </p:txBody>
@@ -2123,32 +2136,22 @@
           <a:lstStyle/>
           <a:p>
             <a:r>
-              <a:t>等方背景の倍率 (本研究 / Totani): 20 GeV 付近で約 0.4 倍、一番低いエネルギー (1.5 GeV) では v20 で約 1/200。</a:t>
-            </a:r>
-          </a:p>
-          <a:p>
-            <a:r>
-              <a:t>Loop I の近い殻: 太陽が殻の壁の中 (半径 62〜81 pc、太陽から中心まで 78 pc) にいるので、ROI 全体を覆い、等方背景と数学的に区別できない (.dev/TOTANI_SPEC.md 3.7a)。</a:t>
-            </a:r>
-          </a:p>
-          <a:p>
-            <a:r>
-              <a:t>空の上の方だけで計算 (|b| ≥ 30°, 40°): 1.5 GeV の等方背景の倍率が 19 倍、55 倍に戻る。Totani 比 0.005 → 0.27 (2026-07-31、MCMC_BMIN)。</a:t>
-            </a:r>
-          </a:p>
-          <a:p>
-            <a:r>
-              <a:t>低いエネルギーでは、GALPROP の出力のスペクトルが Totani と違う (1.5 GeV で 0.56 倍) ことも効いている。</a:t>
-            </a:r>
-          </a:p>
-          <a:p>
-            <a:r>
-              <a:t>全成分の合計の明るさは Totani とほぼ同じ (0.96 倍)、ハロー単独も 1.16 倍。</a:t>
-            </a:r>
-          </a:p>
-          <a:p>
-            <a:r>
-              <a:t>図: 20.8 GeV の型紙、|b| = 20〜40° の帯での横方向の明るさ。作図 /home/arsei/slidework/make_profiles.py</a:t>
+              <a:t>ばらつき = 0 からのずれの 2 乗平均の平方根。光子が十分あるビン 2–10 (2.6–169 GeV) の 207 個から計算。</a:t>
+            </a:r>
+          </a:p>
+          <a:p>
+            <a:r>
+              <a:t>95% 区間はブートストラップ (データを復元抽出し直して何度も計算) で付けた。同じ場所のビン同士は相関する (隣どうし +0.31) ので、場所ごとにまとめて引き直した。</a:t>
+            </a:r>
+          </a:p>
+          <a:p>
+            <a:r>
+              <a:t>較正の仮定: 背景モデル (型紙) の誤りで、σ の分散が一様に 1.26² 倍に膨らむ (統計でいう過分散)。19σ のような大きな値でも同じ倍率かは確かめていない。天の川は背景がもっと複雑なので、本当の倍率はもっと大きいかもしれない (15σ は楽観寄り)。</a:t>
+            </a:r>
+          </a:p>
+          <a:p>
+            <a:r>
+              <a:t>記録の「1.362 (250 個)」は今の結果ファイルからは再現できなかった。最大 4.50σ は最低エネルギー (1.5 GeV) のビン。</a:t>
             </a:r>
           </a:p>
         </p:txBody>
@@ -2218,12 +2221,17 @@
           <a:lstStyle/>
           <a:p>
             <a:r>
-              <a:t>① フェルミバブル = 銀河中心の上下に広がる、ガンマ線で明るい泡状の構造。その矩形 |l| &lt; 22°, 10° &lt; |b| &lt; 55° を当てはめから外した。</a:t>
-            </a:r>
-          </a:p>
-          <a:p>
-            <a:r>
-              <a:t>② 何も無い空 23 か所で同じ解析をした (2026-07-31)。</a:t>
+              <a:t>黒の点: 各エネルギービンで 23 か所から測ったばらつきと 95% 区間。灰色の帯: ビン 2–10 をまとめた値 1.26 とその 95% 区間。</a:t>
+            </a:r>
+          </a:p>
+          <a:p>
+            <a:r>
+              <a:t>灰色の点: 1.5 GeV はばらつき 2.2 の外れ (望遠鏡のぼやけが大きく、背景モデルの誤りが効きやすい)。285 GeV 以上は光子が数個〜数十個で、Wilks の定理の前提 (データが多い) が崩れる。</a:t>
+            </a:r>
+          </a:p>
+          <a:p>
+            <a:r>
+              <a:t>図は slides/figs/plot_null_variance.py で作った。</a:t>
             </a:r>
           </a:p>
         </p:txBody>
@@ -2293,27 +2301,7 @@
           <a:lstStyle/>
           <a:p>
             <a:r>
-              <a:t>フィッシャー情報: 尤度の山の鋭さ (2 階微分)。山が鋭いほどパラメータがよく決まる。</a:t>
-            </a:r>
-          </a:p>
-          <a:p>
-            <a:r>
-              <a:t>「ハローだけの手がかり」= 他の成分と区別できる部分の情報 (フィッシャー行列のシューア補行列)。有意度は、おおよそ「倍率の推定値 ÷ その誤差」で、誤差は情報の平方根に反比例する。</a:t>
-            </a:r>
-          </a:p>
-          <a:p>
-            <a:r>
-              <a:t>予測 6.4σ と実測 5.0σ の残りの差は、バブル外でハローの倍率が 0.77 倍と低いことで説明できる (予測 6.4σ は 10/1 の v20r で計算したフィッシャー情報から。実測と倍率は 10/3 本人 PC、Totani 方式)。この内外の差は約 1.5σ で、意味のある差ではない。</a:t>
-            </a:r>
-          </a:p>
-          <a:p>
-            <a:r>
-              <a:t>対照: 同じ形の矩形を経度方向に ±20°, ±30°, ±38° ずらして外すと 14.6〜16.4σ (Totani と同じやり方)。</a:t>
-            </a:r>
-          </a:p>
-          <a:p>
-            <a:r>
-              <a:t>たとえ: 写真の真ん中を隠すと自信が下がるが、それは見分けるヒントが真ん中に集まっていたから。</a:t>
+              <a:t>言えるのは「既知の背景では説明しにくい超過がある」まで。それが暗黒物質かどうかは別の主張。</a:t>
             </a:r>
           </a:p>
         </p:txBody>
@@ -2383,22 +2371,17 @@
           <a:lstStyle/>
           <a:p>
             <a:r>
-              <a:t>全体の明るさのずれ (ICS が GALPROP の 1.6 倍、など) は倍率が吸収するのでハローにはならない。ハローに化けるには「銀河中心寄りだけ明るい」という形のずれが必要。</a:t>
-            </a:r>
-          </a:p>
-          <a:p>
-            <a:r>
-              <a:t>等方近似: GALPROP の設定が IC_anisotropic = 0。Moskalenko &amp; Strong (2000) Fig. 6 では、非等方にすると 10 GeV 付近で 1.1〜1.3 倍、銀河中心の上より外側のほうが大きい。</a:t>
-            </a:r>
-          </a:p>
-          <a:p>
-            <a:r>
-              <a:t>3 分割 = 星の光・ちり・宇宙背景の光、の 3 種類の光を電子がはね上げたもの。19.0σ と 17.8σ は本人 PC で、Totani と同じやり方で出した値 (10/3、results/mcmc_allbins_gasICS_v20t_icssplit/)。Totani §3.4.4 の同種の確認とも同じ結論。</a:t>
-            </a:r>
-          </a:p>
-          <a:p>
-            <a:r>
-              <a:t>残る可能性: GALPROP の ICS の「空間の形」が、銀河中心寄りで 2.3 倍ずれている場合。今の道具では確かめられない。</a:t>
+              <a:t>矮小銀河 54 個は Local Volume Database (Pace 2025) の確認済みの銀河。何も無い空は |b| &gt; 20° で互いに 20° 以上離した場所。</a:t>
+            </a:r>
+          </a:p>
+          <a:p>
+            <a:r>
+              <a:t>成分は等方・ガス・ICS・点源・ハロー。バブルと Loop I は銀河中心の構造なので入れない。</a:t>
+            </a:r>
+          </a:p>
+          <a:p>
+            <a:r>
+              <a:t>たとえ: 天の川のハローは部屋全体を照らす光なので電球と見分けにくかった。矮小銀河は遠くの豆電球なので、半径 10° の中では電球 (ICS) は平らな背景にしか見えない。</a:t>
             </a:r>
           </a:p>
         </p:txBody>
@@ -2468,22 +2451,17 @@
           <a:lstStyle/>
           <a:p>
             <a:r>
-              <a:t>ばらつき = 0 からのずれの 2 乗平均の平方根。光子が十分あるビン 2–10 (2.6–169 GeV) の 207 個から計算。</a:t>
-            </a:r>
-          </a:p>
-          <a:p>
-            <a:r>
-              <a:t>95% 区間はブートストラップ (データを復元抽出し直して何度も計算) で付けた。同じ場所のビン同士は相関する (隣どうし +0.31) ので、場所ごとにまとめて引き直した。</a:t>
-            </a:r>
-          </a:p>
-          <a:p>
-            <a:r>
-              <a:t>較正の仮定: 背景モデル (型紙) の誤りで、σ の分散が一様に 1.26² 倍に膨らむ (統計でいう過分散)。19σ のような大きな値でも同じ倍率かは確かめていない。天の川は背景がもっと複雑なので、本当の倍率はもっと大きいかもしれない (15σ は楽観寄り)。</a:t>
-            </a:r>
-          </a:p>
-          <a:p>
-            <a:r>
-              <a:t>記録の「1.362 (250 個)」は今の結果ファイルからは再現できなかった。最大 4.50σ は最低エネルギー (1.5 GeV) のビン。</a:t>
+              <a:t>⟨σv⟩: 対消滅の起きやすさ、m: 粒子の質量、dN/dE: 1 回の対消滅で出る光のスペクトル。天の川と矮小銀河で同じエネルギービンを見るので、これらは全部共通。</a:t>
+            </a:r>
+          </a:p>
+          <a:p>
+            <a:r>
+              <a:t>矮小銀河の J は Pace &amp; Strigari (2019) の式: J(0.5°) = 10^17.72 (σ_los / 5 km/s)⁴ (d / 100 kpc)⁻² (r_1/2 / 100 pc)⁻¹ GeV² cm⁻⁵。σ_los は星の速度のばらつき。</a:t>
+            </a:r>
+          </a:p>
+          <a:p>
+            <a:r>
+              <a:t>「何σ見えるはずか」= 予測フラックス ÷ 各天体の測定誤差。</a:t>
             </a:r>
           </a:p>
         </p:txBody>
@@ -2553,27 +2531,17 @@
           <a:lstStyle/>
           <a:p>
             <a:r>
-              <a:t>型紙 (テンプレート) = その光源だけがあったら、空のどこがどれくらい明るいかの地図。</a:t>
-            </a:r>
-          </a:p>
-          <a:p>
-            <a:r>
-              <a:t>ICS (逆コンプトン散乱) = 宇宙線の電子が、星の光などをはね上げてガンマ線にしたもの。</a:t>
-            </a:r>
-          </a:p>
-          <a:p>
-            <a:r>
-              <a:t>GALPROP は ver.54、設定 SLZ6R30T150C2 (Totani と同じ)。</a:t>
-            </a:r>
-          </a:p>
-          <a:p>
-            <a:r>
-              <a:t>ハローは NFW 型 (Via Lactea II: rs = 21 kpc) の密度の 2 乗の視線積分。</a:t>
-            </a:r>
-          </a:p>
-          <a:p>
-            <a:r>
-              <a:t>ハローの倍率を負にも許すのは、「無いもの」を探すときに偏りを作らないため。</a:t>
+              <a:t>Totani (2025) §2.1 と同じ選び方。画素は 0.125°。</a:t>
+            </a:r>
+          </a:p>
+          <a:p>
+            <a:r>
+              <a:t>本研究のデータは 780 週のうち 778 週 (2 週分が欠けている)。</a:t>
+            </a:r>
+          </a:p>
+          <a:p>
+            <a:r>
+              <a:t>銀河面を除くのは、ガスや点源が多すぎて背景の誤差が大きいため。</a:t>
             </a:r>
           </a:p>
         </p:txBody>
@@ -2643,17 +2611,22 @@
           <a:lstStyle/>
           <a:p>
             <a:r>
-              <a:t>黒の点: 各エネルギービンで 23 か所から測ったばらつきと 95% 区間。灰色の帯: ビン 2–10 をまとめた値 1.26 とその 95% 区間。</a:t>
-            </a:r>
-          </a:p>
-          <a:p>
-            <a:r>
-              <a:t>灰色の点: 1.5 GeV はばらつき 2.2 の外れ (望遠鏡のぼやけが大きく、背景モデルの誤りが効きやすい)。285 GeV 以上は光子が数個〜数十個で、Wilks の定理の前提 (データが多い) が崩れる。</a:t>
-            </a:r>
-          </a:p>
-          <a:p>
-            <a:r>
-              <a:t>図は slides/figs/plot_null_variance.py で作った。</a:t>
+              <a:t>黒: 矮小銀河 52 + M31・M33 の全 13 ビンの有意度 (702 個)。灰色: 何も無い空 23 か所 (299 個)。点線: 理論の分布。</a:t>
+            </a:r>
+          </a:p>
+          <a:p>
+            <a:r>
+              <a:t>2 つの分布はほぼ同じ形 = 矮小銀河は「何も無い空」と区別できない。0 付近が高いのは、光子が数個しか無い高エネルギーのビンで σ がほぼ 0 になるため。</a:t>
+            </a:r>
+          </a:p>
+          <a:p>
+            <a:r>
+              <a:t>SMC・LMC はそれ自体が広がったガンマ線源で、解析で中心がマスクされるため使えない (54 − 2 = 52)。</a:t>
+            </a:r>
+          </a:p>
+          <a:p>
+            <a:r>
+              <a:t>図は slides/figs/plot_dwarf_results.py で作った。</a:t>
             </a:r>
           </a:p>
         </p:txBody>
@@ -2723,7 +2696,22 @@
           <a:lstStyle/>
           <a:p>
             <a:r>
-              <a:t>言えるのは「既知の背景では説明しにくい超過がある」まで。それが暗黒物質かどうかは別の主張。</a:t>
+              <a:t>予測が大きい天体ほど重く数える重み付き和。予測のパターンが分かっているときに、いちばん検出しやすいまとめ方。</a:t>
+            </a:r>
+          </a:p>
+          <a:p>
+            <a:r>
+              <a:t>43 天体 = 星の速度のばらつき σ_los が測られていて J が出せる矮小銀河 (SMC・LMC は除く)。</a:t>
+            </a:r>
+          </a:p>
+          <a:p>
+            <a:r>
+              <a:t>ずれ = (1.77 − 0.39) ÷ 1 = 1.4σ。天の川のハローの明るさは Totani と同じやり方の最良値。天の川側の局所密度 0.42 GeV/cm³ の場合。</a:t>
+            </a:r>
+          </a:p>
+          <a:p>
+            <a:r>
+              <a:t>注意: 9/28 の計算は SMC・LMC を誤って含めていた (予測 2.69σ のうち 2.06σ が SMC 1 天体)。</a:t>
             </a:r>
           </a:p>
         </p:txBody>
@@ -2793,17 +2781,27 @@
           <a:lstStyle/>
           <a:p>
             <a:r>
-              <a:t>矮小銀河 54 個は Local Volume Database (Pace 2025) の確認済みの銀河。何も無い空は |b| &gt; 20° で互いに 20° 以上離した場所。</a:t>
-            </a:r>
-          </a:p>
-          <a:p>
-            <a:r>
-              <a:t>成分は等方・ガス・ICS・点源・ハロー。バブルと Loop I は銀河中心の構造なので入れない。</a:t>
-            </a:r>
-          </a:p>
-          <a:p>
-            <a:r>
-              <a:t>たとえ: 天の川のハローは部屋全体を照らす光なので電球と見分けにくかった。矮小銀河は遠くの豆電球なので、半径 10° の中では電球 (ICS) は平らな背景にしか見えない。</a:t>
+              <a:t>Section II と Fig. 1 の内容。</a:t>
+            </a:r>
+          </a:p>
+          <a:p>
+            <a:r>
+              <a:t>dex = 対数で 1 桁。0.4 dex は約 2.5 倍、0.1 は約 1.26 倍、0.3 は約 2 倍。</a:t>
+            </a:r>
+          </a:p>
+          <a:p>
+            <a:r>
+              <a:t>非球対称: 楕円体の矮小銀河を球対称の NFW で解析すると、log10 J が最大 0.4 ずれる。</a:t>
+            </a:r>
+          </a:p>
+          <a:p>
+            <a:r>
+              <a:t>連星: 見分けられていない連星があると星の速度のばらつきが大きく見え、J を大きく見積もる (Reticulum II で約 0.3)。</a:t>
+            </a:r>
+          </a:p>
+          <a:p>
+            <a:r>
+              <a:t>誤差の分布: 多くの解析は log J の誤差を正規分布と仮定するが、本当の分布はすそが重い。</a:t>
             </a:r>
           </a:p>
         </p:txBody>
@@ -2873,17 +2871,22 @@
           <a:lstStyle/>
           <a:p>
             <a:r>
-              <a:t>⟨σv⟩: 対消滅の起きやすさ、m: 粒子の質量、dN/dE: 1 回の対消滅で出る光のスペクトル。天の川と矮小銀河で同じエネルギービンを見るので、これらは全部共通。</a:t>
-            </a:r>
-          </a:p>
-          <a:p>
-            <a:r>
-              <a:t>矮小銀河の J は Pace &amp; Strigari (2019) の式: J(0.5°) = 10^17.72 (σ_los / 5 km/s)⁴ (d / 100 kpc)⁻² (r_1/2 / 100 pc)⁻¹ GeV² cm⁻⁵。σ_los は星の速度のばらつき。</a:t>
-            </a:r>
-          </a:p>
-          <a:p>
-            <a:r>
-              <a:t>「何σ見えるはずか」= 予測フラックス ÷ 各天体の測定誤差。</a:t>
+              <a:t>Section III。FermiTools v2.5.1、fermipy v1.4.0。事象は P8R3 SOURCE V3、4 つの PSF クラス、エネルギーは 1 桁あたり 8 ビン。</a:t>
+            </a:r>
+          </a:p>
+          <a:p>
+            <a:r>
+              <a:t>背景の型紙: gll_iem_v07 (銀河拡散) と等方。点源カタログ (4FGL) の天体は簡単のため入れていない。</a:t>
+            </a:r>
+          </a:p>
+          <a:p>
+            <a:r>
+              <a:t>信号の空間の形: 古典的な矮小銀河は芯のある NFW (cNFW)、超微光の矮小銀河は切断した NFW。</a:t>
+            </a:r>
+          </a:p>
+          <a:p>
+            <a:r>
+              <a:t>本当の J (J_true) は Table I の中心値。</a:t>
             </a:r>
           </a:p>
         </p:txBody>
@@ -2953,22 +2956,22 @@
           <a:lstStyle/>
           <a:p>
             <a:r>
-              <a:t>黒: 矮小銀河 52 + M31・M33 の全 13 ビンの有意度 (702 個)。灰色: 何も無い空 23 か所 (299 個)。点線: 理論の分布。</a:t>
-            </a:r>
-          </a:p>
-          <a:p>
-            <a:r>
-              <a:t>2 つの分布はほぼ同じ形 = 矮小銀河は「何も無い空」と区別できない。0 付近が高いのは、光子が数個しか無い高エネルギーのビンで σ がほぼ 0 になるため。</a:t>
-            </a:r>
-          </a:p>
-          <a:p>
-            <a:r>
-              <a:t>SMC・LMC はそれ自体が広がったガンマ線源で、解析で中心がマスクされるため使えない (54 − 2 = 52)。</a:t>
-            </a:r>
-          </a:p>
-          <a:p>
-            <a:r>
-              <a:t>図は slides/figs/plot_dwarf_results.py で作った。</a:t>
+              <a:t>式 (6)〜(10)。J_obs = 星の動きの解析で出た値 (観測値)、J_true = 本当の値。</a:t>
+            </a:r>
+          </a:p>
+          <a:p>
+            <a:r>
+              <a:t>σ_L が小さい = 解析ソフトが「J はほぼ分かっている」と自信を持ちすぎている状態。</a:t>
+            </a:r>
+          </a:p>
+          <a:p>
+            <a:r>
+              <a:t>J は「局外パラメータ」(知りたいのは ⟨σv⟩ だが、決めないといけない他のパラメータ) で、尤度を最大にする値に置き換えて (プロファイル) から ⟨σv⟩ を調べる。</a:t>
+            </a:r>
+          </a:p>
+          <a:p>
+            <a:r>
+              <a:t>TS = 2 ln [ L(⟨σv⟩) / L(0) ]。</a:t>
             </a:r>
           </a:p>
         </p:txBody>
@@ -3038,22 +3041,12 @@
           <a:lstStyle/>
           <a:p>
             <a:r>
-              <a:t>予測が大きい天体ほど重く数える重み付き和。予測のパターンが分かっているときに、いちばん検出しやすいまとめ方。</a:t>
-            </a:r>
-          </a:p>
-          <a:p>
-            <a:r>
-              <a:t>43 天体 = 星の速度のばらつき σ_los が測られていて J が出せる矮小銀河 (SMC・LMC は除く)。</a:t>
-            </a:r>
-          </a:p>
-          <a:p>
-            <a:r>
-              <a:t>ずれ = (1.77 − 0.39) ÷ 1 = 1.4σ。天の川のハローの明るさは Totani と同じやり方の最良値。天の川側の局所密度 0.42 GeV/cm³ の場合。</a:t>
-            </a:r>
-          </a:p>
-          <a:p>
-            <a:r>
-              <a:t>注意: 9/28 の計算は SMC・LMC を誤って含めていた (予測 2.69σ のうち 2.06σ が SMC 1 天体)。</a:t>
+              <a:t>答えが分かっている仮想の宇宙で、解析が正しく答えを出せるかを試している。</a:t>
+            </a:r>
+          </a:p>
+          <a:p>
+            <a:r>
+              <a:t>カバレッジが足りない (アンダーカバレッジ) = 95% と言いながら、本物を 5% より多く除外してしまう。</a:t>
             </a:r>
           </a:p>
         </p:txBody>
@@ -3123,27 +3116,22 @@
           <a:lstStyle/>
           <a:p>
             <a:r>
-              <a:t>Section II と Fig. 1 の内容。</a:t>
-            </a:r>
-          </a:p>
-          <a:p>
-            <a:r>
-              <a:t>dex = 対数で 1 桁。0.4 dex は約 2.5 倍、0.1 は約 1.26 倍、0.3 は約 2 倍。</a:t>
-            </a:r>
-          </a:p>
-          <a:p>
-            <a:r>
-              <a:t>非球対称: 楕円体の矮小銀河を球対称の NFW で解析すると、log10 J が最大 0.4 ずれる。</a:t>
-            </a:r>
-          </a:p>
-          <a:p>
-            <a:r>
-              <a:t>連星: 見分けられていない連星があると星の速度のばらつきが大きく見え、J を大きく見積もる (Reticulum II で約 0.3)。</a:t>
-            </a:r>
-          </a:p>
-          <a:p>
-            <a:r>
-              <a:t>誤差の分布: 多くの解析は log J の誤差を正規分布と仮定するが、本当の分布はすそが重い。</a:t>
+              <a:t>誤差を「大きくする」は 2 乗和で足す: σ_L² = σ_cat² + 0.3² など。σ_cat はカタログに書かれた誤差。</a:t>
+            </a:r>
+          </a:p>
+          <a:p>
+            <a:r>
+              <a:t>Ursa Minor: 距離 76 kpc、log10 J_tot = 18.55 ± 0.05、見かけの広がり 0.59° (望遠鏡のぼやけより大きい)。</a:t>
+            </a:r>
+          </a:p>
+          <a:p>
+            <a:r>
+              <a:t>基準 (σ = σ_cat) では 1 万回中 0 回しか本物を除外しない (過大なカバレッジ)。J と ⟨σv⟩ の縮退で Wilks の定理が成り立たないため。</a:t>
+            </a:r>
+          </a:p>
+          <a:p>
+            <a:r>
+              <a:t>形: 本当は楕円の cNFW。楕円かどうかはあまり効かず、中心の尖り方と広がりが効く。</a:t>
             </a:r>
           </a:p>
         </p:txBody>
@@ -3213,22 +3201,27 @@
           <a:lstStyle/>
           <a:p>
             <a:r>
-              <a:t>Section III。FermiTools v2.5.1、fermipy v1.4.0。事象は P8R3 SOURCE V3、4 つの PSF クラス、エネルギーは 1 桁あたり 8 ビン。</a:t>
-            </a:r>
-          </a:p>
-          <a:p>
-            <a:r>
-              <a:t>背景の型紙: gll_iem_v07 (銀河拡散) と等方。点源カタログ (4FGL) の天体は簡単のため入れていない。</a:t>
-            </a:r>
-          </a:p>
-          <a:p>
-            <a:r>
-              <a:t>信号の空間の形: 古典的な矮小銀河は芯のある NFW (cNFW)、超微光の矮小銀河は切断した NFW。</a:t>
-            </a:r>
-          </a:p>
-          <a:p>
-            <a:r>
-              <a:t>本当の J (J_true) は Table I の中心値。</a:t>
+              <a:t>Section V。上限が 1 個のときよりゆるくなりにくいのは、J が大きい天体ほどカタログの誤差が大きいので、同じ量を足しても割合が小さいため。</a:t>
+            </a:r>
+          </a:p>
+          <a:p>
+            <a:r>
+              <a:t>Wilks の定理は「局外パラメータの数が少ない」ことを前提にする。27 個まとめると J が 27 個あり、前提が崩れる。</a:t>
+            </a:r>
+          </a:p>
+          <a:p>
+            <a:r>
+              <a:t>J_obs は対数で正規分布 → J そのものでは上に長いすそ。上に振れた天体が上限を強く引っ張り、下に振れた天体では打ち消せない。27 個のうち 1 個以上が 1.5σ 以上上に振れる確率は約 0.85。</a:t>
+            </a:r>
+          </a:p>
+          <a:p>
+            <a:r>
+              <a:t>全部を点として扱うと 37%。</a:t>
+            </a:r>
+          </a:p>
+          <a:p>
+            <a:r>
+              <a:t>何も無い領域 (blank field) での較正は Ref. [76] の方法。</a:t>
             </a:r>
           </a:p>
         </p:txBody>
@@ -3298,22 +3291,7 @@
           <a:lstStyle/>
           <a:p>
             <a:r>
-              <a:t>式 (6)〜(10)。J_obs = 星の動きの解析で出た値 (観測値)、J_true = 本当の値。</a:t>
-            </a:r>
-          </a:p>
-          <a:p>
-            <a:r>
-              <a:t>σ_L が小さい = 解析ソフトが「J はほぼ分かっている」と自信を持ちすぎている状態。</a:t>
-            </a:r>
-          </a:p>
-          <a:p>
-            <a:r>
-              <a:t>J は「局外パラメータ」(知りたいのは ⟨σv⟩ だが、決めないといけない他のパラメータ) で、尤度を最大にする値に置き換えて (プロファイル) から ⟨σv⟩ を調べる。</a:t>
-            </a:r>
-          </a:p>
-          <a:p>
-            <a:r>
-              <a:t>TS = 2 ln [ L(⟨σv⟩) / L(0) ]。</a:t>
+              <a:t>Section VI。「矮小銀河で信号が無くて当然」とまでは言っていない。「無いから暗黒物質ではない」と判断するのが早すぎるかもしれない、という主張。</a:t>
             </a:r>
           </a:p>
         </p:txBody>
@@ -3383,12 +3361,107 @@
           <a:lstStyle/>
           <a:p>
             <a:r>
-              <a:t>答えが分かっている仮想の宇宙で、解析が正しく答えを出せるかを試している。</a:t>
-            </a:r>
-          </a:p>
-          <a:p>
-            <a:r>
-              <a:t>カバレッジが足りない (アンダーカバレッジ) = 95% と言いながら、本物を 5% より多く除外してしまう。</a:t>
+              <a:t>論文の Section IV で J_obs を J_true のまわりに対数正規でばらつかせたのと同じ考え方。幅 0.5 は論文の推奨値 (abstract)。</a:t>
+            </a:r>
+          </a:p>
+          <a:p>
+            <a:r>
+              <a:t>言い方: J がどれくらいずれているか分からないので、サイコロを振って J をずらして予測を出す、を 20 万回繰り返した。そうすると「予測はだいたいこの範囲」という幅が分かる。</a:t>
+            </a:r>
+          </a:p>
+          <a:p>
+            <a:r>
+              <a:t>スクリプト: cloud_reports/2026-10-02_dwarf_J_uncertainty.py。</a:t>
+            </a:r>
+          </a:p>
+        </p:txBody>
+      </p:sp>
+      <p:sp>
+        <p:nvSpPr>
+          <p:cNvPr id="4" name="Slide Number Placeholder 3"/>
+          <p:cNvSpPr>
+            <a:spLocks noGrp="1"/>
+          </p:cNvSpPr>
+          <p:nvPr>
+            <p:ph type="sldNum" sz="quarter" idx="5"/>
+          </p:nvPr>
+        </p:nvSpPr>
+        <p:spPr/>
+      </p:sp>
+    </p:spTree>
+  </p:cSld>
+  <p:clrMapOvr>
+    <a:masterClrMapping/>
+  </p:clrMapOvr>
+</p:notes>
+</file>
+
+<file path=ppt/notesSlides/notesSlide4.xml><?xml version="1.0" encoding="utf-8"?>
+<p:notes xmlns:a="http://schemas.openxmlformats.org/drawingml/2006/main" xmlns:r="http://schemas.openxmlformats.org/officeDocument/2006/relationships" xmlns:p="http://schemas.openxmlformats.org/presentationml/2006/main">
+  <p:cSld>
+    <p:spTree>
+      <p:nvGrpSpPr>
+        <p:cNvPr id="1" name=""/>
+        <p:cNvGrpSpPr/>
+        <p:nvPr/>
+      </p:nvGrpSpPr>
+      <p:grpSpPr>
+        <a:xfrm>
+          <a:off x="0" y="0"/>
+          <a:ext cx="0" cy="0"/>
+          <a:chOff x="0" y="0"/>
+          <a:chExt cx="0" cy="0"/>
+        </a:xfrm>
+      </p:grpSpPr>
+      <p:sp>
+        <p:nvSpPr>
+          <p:cNvPr id="2" name="Slide Image Placeholder 1"/>
+          <p:cNvSpPr>
+            <a:spLocks noGrp="1" noRot="1" noChangeAspect="1"/>
+          </p:cNvSpPr>
+          <p:nvPr>
+            <p:ph type="sldImg" idx="2"/>
+          </p:nvPr>
+        </p:nvSpPr>
+        <p:spPr/>
+      </p:sp>
+      <p:sp>
+        <p:nvSpPr>
+          <p:cNvPr id="3" name="Notes Placeholder 2"/>
+          <p:cNvSpPr>
+            <a:spLocks noGrp="1"/>
+          </p:cNvSpPr>
+          <p:nvPr>
+            <p:ph type="body" sz="quarter" idx="3"/>
+          </p:nvPr>
+        </p:nvSpPr>
+        <p:spPr/>
+        <p:txBody>
+          <a:bodyPr/>
+          <a:lstStyle/>
+          <a:p>
+            <a:r>
+              <a:t>型紙 (テンプレート) = その光源だけがあったら、空のどこがどれくらい明るいかの地図。</a:t>
+            </a:r>
+          </a:p>
+          <a:p>
+            <a:r>
+              <a:t>ICS (逆コンプトン散乱) = 宇宙線の電子が、星の光などをはね上げてガンマ線にしたもの。</a:t>
+            </a:r>
+          </a:p>
+          <a:p>
+            <a:r>
+              <a:t>GALPROP は ver.54、設定 SLZ6R30T150C2 (Totani と同じ)。</a:t>
+            </a:r>
+          </a:p>
+          <a:p>
+            <a:r>
+              <a:t>ハローは NFW 型 (Via Lactea II: rs = 21 kpc) の密度の 2 乗の視線積分。</a:t>
+            </a:r>
+          </a:p>
+          <a:p>
+            <a:r>
+              <a:t>ハローの倍率を負にも許すのは、「無いもの」を探すときに偏りを作らないため。</a:t>
             </a:r>
           </a:p>
         </p:txBody>
@@ -3458,22 +3531,17 @@
           <a:lstStyle/>
           <a:p>
             <a:r>
-              <a:t>誤差を「大きくする」は 2 乗和で足す: σ_L² = σ_cat² + 0.3² など。σ_cat はカタログに書かれた誤差。</a:t>
-            </a:r>
-          </a:p>
-          <a:p>
-            <a:r>
-              <a:t>Ursa Minor: 距離 76 kpc、log10 J_tot = 18.55 ± 0.05、見かけの広がり 0.59° (望遠鏡のぼやけより大きい)。</a:t>
-            </a:r>
-          </a:p>
-          <a:p>
-            <a:r>
-              <a:t>基準 (σ = σ_cat) では 1 万回中 0 回しか本物を除外しない (過大なカバレッジ)。J と ⟨σv⟩ の縮退で Wilks の定理が成り立たないため。</a:t>
-            </a:r>
-          </a:p>
-          <a:p>
-            <a:r>
-              <a:t>形: 本当は楕円の cNFW。楕円かどうかはあまり効かず、中心の尖り方と広がりが効く。</a:t>
+              <a:t>重み w_i は今まで通り J の推定値から出した予測 pred_i のまま (解析する人は本当の J を知らないため)。</a:t>
+            </a:r>
+          </a:p>
+          <a:p>
+            <a:r>
+              <a:t>Φ = 標準正規分布の累積分布関数。p は片側。ずれ = 標準正規で p に対応する σ。</a:t>
+            </a:r>
+          </a:p>
+          <a:p>
+            <a:r>
+              <a:t>J の誤差は「期待の中央値」を少し上げる。対数正規は上に長いすそを持つので、合計が上に引っ張られる (論文 Section V と同じ現象)。</a:t>
             </a:r>
           </a:p>
         </p:txBody>
@@ -3543,27 +3611,17 @@
           <a:lstStyle/>
           <a:p>
             <a:r>
-              <a:t>Section V。上限が 1 個のときよりゆるくなりにくいのは、J が大きい天体ほどカタログの誤差が大きいので、同じ量を足しても割合が小さいため。</a:t>
-            </a:r>
-          </a:p>
-          <a:p>
-            <a:r>
-              <a:t>Wilks の定理は「局外パラメータの数が少ない」ことを前提にする。27 個まとめると J が 27 個あり、前提が崩れる。</a:t>
-            </a:r>
-          </a:p>
-          <a:p>
-            <a:r>
-              <a:t>J_obs は対数で正規分布 → J そのものでは上に長いすそ。上に振れた天体が上限を強く引っ張り、下に振れた天体では打ち消せない。27 個のうち 1 個以上が 1.5σ 以上上に振れる確率は約 0.85。</a:t>
-            </a:r>
-          </a:p>
-          <a:p>
-            <a:r>
-              <a:t>全部を点として扱うと 37%。</a:t>
-            </a:r>
-          </a:p>
-          <a:p>
-            <a:r>
-              <a:t>何も無い領域 (blank field) での較正は Ref. [76] の方法。</a:t>
+              <a:t>灰色の山: J の誤差を入れたときの予測の分布 (20 万回)。点線: J の誤差なしの予測 1.77。黒い点: 実測 0.39、横棒は測定の揺れ ±1.26。</a:t>
+            </a:r>
+          </a:p>
+          <a:p>
+            <a:r>
+              <a:t>点は山の左にあるが、横棒が山に届いているので、ずれは約 1.3σ で「たまたま」で起きる範囲。</a:t>
+            </a:r>
+          </a:p>
+          <a:p>
+            <a:r>
+              <a:t>図は slides/figs/plot_dwarf_J.py で作った。</a:t>
             </a:r>
           </a:p>
         </p:txBody>
@@ -3633,7 +3691,22 @@
           <a:lstStyle/>
           <a:p>
             <a:r>
-              <a:t>Section VI。「矮小銀河で信号が無くて当然」とまでは言っていない。「無いから暗黒物質ではない」と判断するのが早すぎるかもしれない、という主張。</a:t>
+              <a:t>予測は天の川側の局所密度 ρ☉ の −2 乗に比例する (天の川の J が密度の 2 乗に比例し、天の川の実測の明るさは固定のため)。</a:t>
+            </a:r>
+          </a:p>
+          <a:p>
+            <a:r>
+              <a:t>ρ☉ = 0.3: 期待 3.46 (誤差なし) / 4.86 (誤差あり、68% 2.64–9.95)、ずれ 2.4σ / 2.1σ (s = 1.26)。</a:t>
+            </a:r>
+          </a:p>
+          <a:p>
+            <a:r>
+              <a:t>ρ☉ = 0.6: 期待 0.87 / 1.21 (0.66–2.49)、ずれ 0.4σ / 0.7σ。</a:t>
+            </a:r>
+          </a:p>
+          <a:p>
+            <a:r>
+              <a:t>J の誤差を入れると、期待の幅が大きく広がり、「判定できない」がより強くなる。</a:t>
             </a:r>
           </a:p>
         </p:txBody>
@@ -3703,17 +3776,12 @@
           <a:lstStyle/>
           <a:p>
             <a:r>
-              <a:t>論文の Section IV で J_obs を J_true のまわりに対数正規でばらつかせたのと同じ考え方。幅 0.5 は論文の推奨値 (abstract)。</a:t>
-            </a:r>
-          </a:p>
-          <a:p>
-            <a:r>
-              <a:t>言い方: J がどれくらいずれているか分からないので、サイコロを振って J をずらして予測を出す、を 20 万回繰り返した。そうすると「予測はだいたいこの範囲」という幅が分かる。</a:t>
-            </a:r>
-          </a:p>
-          <a:p>
-            <a:r>
-              <a:t>スクリプト: cloud_reports/2026-10-02_dwarf_J_uncertainty.py。</a:t>
+              <a:t>15σ は「ハローがあるか」の強さ、1.3σ は「天の川と矮小銀河が食い違うか」の強さ。</a:t>
+            </a:r>
+          </a:p>
+          <a:p>
+            <a:r>
+              <a:t>どちらも Wilks の定理だけに頼らず、何も無い空で較正した値 (1.26) を使っている。</a:t>
             </a:r>
           </a:p>
         </p:txBody>
@@ -3783,17 +3851,7 @@
           <a:lstStyle/>
           <a:p>
             <a:r>
-              <a:t>重み w_i は今まで通り J の推定値から出した予測 pred_i のまま (解析する人は本当の J を知らないため)。</a:t>
-            </a:r>
-          </a:p>
-          <a:p>
-            <a:r>
-              <a:t>Φ = 標準正規分布の累積分布関数。p は片側。ずれ = 標準正規で p に対応する σ。</a:t>
-            </a:r>
-          </a:p>
-          <a:p>
-            <a:r>
-              <a:t>J の誤差は「期待の中央値」を少し上げる。対数正規は上に長いすそを持つので、合計が上に引っ張られる (論文 Section V と同じ現象)。</a:t>
+              <a:t>流れ: 再現 → 縮退による 3 つの疑問 → 背景の間違い説を否定・σ を較正・記録を整備 → 矮小銀河は非検出 → 論文の J の誤差を入れて「判定できない」を定量化。</a:t>
             </a:r>
           </a:p>
         </p:txBody>
@@ -3863,17 +3921,22 @@
           <a:lstStyle/>
           <a:p>
             <a:r>
-              <a:t>灰色の山: J の誤差を入れたときの予測の分布 (20 万回)。点線: J の誤差なしの予測 1.77。黒い点: 実測 0.39、横棒は測定の揺れ ±1.26。</a:t>
-            </a:r>
-          </a:p>
-          <a:p>
-            <a:r>
-              <a:t>点は山の左にあるが、横棒が山に届いているので、ずれは約 1.3σ で「たまたま」で起きる範囲。</a:t>
-            </a:r>
-          </a:p>
-          <a:p>
-            <a:r>
-              <a:t>図は slides/figs/plot_dwarf_J.py で作った。</a:t>
+              <a:t>中村 (2017) 講究録 §2: 状態空間モデル。システムノイズ (シミュレーションの誤差) と観測ノイズ (観測の誤差) を分けて書く。</a:t>
+            </a:r>
+          </a:p>
+          <a:p>
+            <a:r>
+              <a:t>§2.3.3–2.3.4: アンサンブルカルマンフィルタ・粒子フィルタは、確率分布をたくさんのサンプル (アンサンブル) で近似する (式 11)。</a:t>
+            </a:r>
+          </a:p>
+          <a:p>
+            <a:r>
+              <a:t>§3.3: モデル化誤差と数値計算の誤差を、システムノイズとして統一的に扱えることがデータ同化の利点。</a:t>
+            </a:r>
+          </a:p>
+          <a:p>
+            <a:r>
+              <a:t>正直な位置づけ: この解析は講究録を読む前に行った。後から読んで、同じ発想だと分かった。データ同化の中心は時間とともに変わる現象で、1 枚の空の地図にそのまま使える手法ではない。</a:t>
             </a:r>
           </a:p>
         </p:txBody>
@@ -3942,24 +4005,7 @@
           <a:bodyPr/>
           <a:lstStyle/>
           <a:p>
-            <a:r>
-              <a:t>予測は天の川側の局所密度 ρ☉ の −2 乗に比例する (天の川の J が密度の 2 乗に比例し、天の川の実測の明るさは固定のため)。</a:t>
-            </a:r>
-          </a:p>
-          <a:p>
-            <a:r>
-              <a:t>ρ☉ = 0.3: 期待 3.46 (誤差なし) / 4.86 (誤差あり、68% 2.64–9.95)、ずれ 2.4σ / 2.1σ (s = 1.26)。</a:t>
-            </a:r>
-          </a:p>
-          <a:p>
-            <a:r>
-              <a:t>ρ☉ = 0.6: 期待 0.87 / 1.21 (0.66–2.49)、ずれ 0.4σ / 0.7σ。</a:t>
-            </a:r>
-          </a:p>
-          <a:p>
-            <a:r>
-              <a:t>J の誤差を入れると、期待の幅が大きく広がり、「判定できない」がより強くなる。</a:t>
-            </a:r>
+            <a:endParaRPr/>
           </a:p>
         </p:txBody>
       </p:sp>
@@ -3983,7 +4029,7 @@
 </p:notes>
 </file>
 
-<file path=ppt/notesSlides/notesSlide47.xml><?xml version="1.0" encoding="utf-8"?>
+<file path=ppt/notesSlides/notesSlide5.xml><?xml version="1.0" encoding="utf-8"?>
 <p:notes xmlns:a="http://schemas.openxmlformats.org/drawingml/2006/main" xmlns:r="http://schemas.openxmlformats.org/officeDocument/2006/relationships" xmlns:p="http://schemas.openxmlformats.org/presentationml/2006/main">
   <p:cSld>
     <p:spTree>
@@ -4028,12 +4074,137 @@
           <a:lstStyle/>
           <a:p>
             <a:r>
-              <a:t>15σ は「ハローがあるか」の強さ、1.3σ は「天の川と矮小銀河が食い違うか」の強さ。</a:t>
-            </a:r>
-          </a:p>
-          <a:p>
-            <a:r>
-              <a:t>どちらも Wilks の定理だけに頼らず、何も無い空で較正した値 (1.26) を使っている。</a:t>
+              <a:t>地図はどれも 20.8 GeV の型紙 (倍率は掛けていない。形だけを見る図)。Loop I は殻 1、バブルは正の型紙。</a:t>
+            </a:r>
+          </a:p>
+          <a:p>
+            <a:r>
+              <a:t>以下は、まとめる前の 6 枚のノート (詳しい説明)。</a:t>
+            </a:r>
+          </a:p>
+          <a:p>
+            <a:r>
+              <a:t>【① 等方背景】たとえ: 部屋の壁全体がぼんやり同じ明るさで光っている、その「底上げ」の明るさ。</a:t>
+            </a:r>
+          </a:p>
+          <a:p>
+            <a:r>
+              <a:t>最初の値 10⁻⁴ は、これまでに測られた「銀河の外から来るガンマ線の背景」の典型的な明るさ (Totani §2.3)。</a:t>
+            </a:r>
+          </a:p>
+          <a:p>
+            <a:r>
+              <a:t>Loop I との区別: 殻 1 は太陽が殻の壁の中にあるため空のほぼ全体を覆い、明るさの変化が等方背景と同じくらい平ら。データからは 2 つの分け方が決まらず、合計だけが決まる (.dev/TOTANI_SPEC.md 3.7a)。</a:t>
+            </a:r>
+          </a:p>
+          <a:p>
+            <a:r>
+              <a:t>右の地図: 20.8 GeV の型紙 (倍率は掛けていない。形だけを見る図)。cloud_reports/2026-10-02_plot_templates.py で作成。</a:t>
+            </a:r>
+          </a:p>
+          <a:p>
+            <a:r>
+              <a:t>【② ガス】GALPROP: 宇宙線が銀河の中でどう生まれ、どう広がるかを計算し、そこから出るガンマ線の地図を作るシミュレーション (ver. 54、設定 SLZ6R30T150C2。Fermi-LAT チームの銀河拡散モデルでも使われている設定)。</a:t>
+            </a:r>
+          </a:p>
+          <a:p>
+            <a:r>
+              <a:t>π⁰ は電気を持たない中間子で、できるとすぐ (10⁻¹⁶ 秒ほど) 光子 2 個に壊れる。</a:t>
+            </a:r>
+          </a:p>
+          <a:p>
+            <a:r>
+              <a:t>ガス雲の模様は、電波 (水素の 21 cm 線) や、ちりによる星の光の赤み (E(B−V)) から作ったガスの地図に由来する。</a:t>
+            </a:r>
+          </a:p>
+          <a:p>
+            <a:r>
+              <a:t>右の地図: 20.8 GeV の型紙 (倍率は掛けていない。形だけを見る図)。cloud_reports/2026-10-02_plot_templates.py で作成。</a:t>
+            </a:r>
+          </a:p>
+          <a:p>
+            <a:r>
+              <a:t>【③ ICS】逆コンプトン散乱: 普通のコンプトン散乱は光が電子をはね飛ばす。ここでは逆で、とても速い電子が、低いエネルギーの光にエネルギーを渡して、ガンマ線にする。</a:t>
+            </a:r>
+          </a:p>
+          <a:p>
+            <a:r>
+              <a:t>ガスの型紙と違って雲の模様が無く、なめらか。ハローもなめらかで中心に向かって明るいので、2 つの形が似ている (問題のスライドで説明する縮退)。</a:t>
+            </a:r>
+          </a:p>
+          <a:p>
+            <a:r>
+              <a:t>GALPROP の設定は IC_anisotropic = 0 (等方近似)。</a:t>
+            </a:r>
+          </a:p>
+          <a:p>
+            <a:r>
+              <a:t>右の地図: 20.8 GeV の型紙 (倍率は掛けていない。形だけを見る図)。cloud_reports/2026-10-02_plot_templates.py で作成。</a:t>
+            </a:r>
+          </a:p>
+          <a:p>
+            <a:r>
+              <a:t>【④ 点源】4FGL-DR4: Fermi-LAT の 14 年分のデータで見つかった天体のカタログ (gll_psc_v35.fit)。</a:t>
+            </a:r>
+          </a:p>
+          <a:p>
+            <a:r>
+              <a:t>PSF (点広がり関数): 望遠鏡で点を撮っても少しぼやけて写る、そのぼやけ方。エネルギーが低いほど大きくぼやける (1 GeV で約 0.85°、10 GeV で約 0.16°)。</a:t>
+            </a:r>
+          </a:p>
+          <a:p>
+            <a:r>
+              <a:t>拡張源: 大マゼラン雲や Cen A のローブのように、点ではなく広がって見える天体。Totani §2.3 と同じく、長半径の 2 倍の円を外す。</a:t>
+            </a:r>
+          </a:p>
+          <a:p>
+            <a:r>
+              <a:t>右の地図: 20.8 GeV の型紙 (倍率は掛けていない。形だけを見る図)。cloud_reports/2026-10-02_plot_templates.py で作成。</a:t>
+            </a:r>
+          </a:p>
+          <a:p>
+            <a:r>
+              <a:t>【⑤ Loop I】pc (パーセク) は距離の単位で、1 pc ≈ 3.26 光年。太陽から殻の中心までは 78 pc と 95 pc。</a:t>
+            </a:r>
+          </a:p>
+          <a:p>
+            <a:r>
+              <a:t>殻 1 は太陽が殻の壁の中にあるので、空のほぼ全体を覆う (左の地図)。そのため等方背景と区別しにくい。</a:t>
+            </a:r>
+          </a:p>
+          <a:p>
+            <a:r>
+              <a:t>超新星の残骸: 星が爆発したときに吹き飛んだガスが、泡のように広がったもの。</a:t>
+            </a:r>
+          </a:p>
+          <a:p>
+            <a:r>
+              <a:t>右の地図: 20.8 GeV の型紙 (倍率は掛けていない。形だけを見る図)。cloud_reports/2026-10-02_plot_templates.py で作成。</a:t>
+            </a:r>
+          </a:p>
+          <a:p>
+            <a:r>
+              <a:t>【⑥ フェルミバブル】なぜデータから作るか: バブルの正確な形を予言する理論が無いため。Totani は Fermi-LAT チームのやり方にならい、当てはめの残りから形を作った。</a:t>
+            </a:r>
+          </a:p>
+          <a:p>
+            <a:r>
+              <a:t>4.3 GeV の地図を使うのは、バブルがはっきり見えるため (Totani §3.1)。形はエネルギーで変えず、明るさ (倍率) だけを各エネルギーで決める。</a:t>
+            </a:r>
+          </a:p>
+          <a:p>
+            <a:r>
+              <a:t>負の型紙: 当てはめで光が余らなかった (予測が多すぎた) 場所。主に GALPROP の予測とデータのずれ。符号自由の倍率を掛けて補正に使う。</a:t>
+            </a:r>
+          </a:p>
+          <a:p>
+            <a:r>
+              <a:t>左の地図が正、右が負 (負の残差の大きさ)。</a:t>
+            </a:r>
+          </a:p>
+          <a:p>
+            <a:r>
+              <a:t>右の地図: 20.8 GeV の型紙 (倍率は掛けていない。形だけを見る図)。cloud_reports/2026-10-02_plot_templates.py で作成。</a:t>
             </a:r>
           </a:p>
         </p:txBody>
@@ -4058,7 +4229,7 @@
 </p:notes>
 </file>
 
-<file path=ppt/notesSlides/notesSlide48.xml><?xml version="1.0" encoding="utf-8"?>
+<file path=ppt/notesSlides/notesSlide6.xml><?xml version="1.0" encoding="utf-8"?>
 <p:notes xmlns:a="http://schemas.openxmlformats.org/drawingml/2006/main" xmlns:r="http://schemas.openxmlformats.org/officeDocument/2006/relationships" xmlns:p="http://schemas.openxmlformats.org/presentationml/2006/main">
   <p:cSld>
     <p:spTree>
@@ -4103,7 +4274,22 @@
           <a:lstStyle/>
           <a:p>
             <a:r>
-              <a:t>流れ: 再現 → 縮退による 3 つの疑問 → 背景の間違い説を否定・σ を較正・記録を整備 → 矮小銀河は非検出 → 論文の J の誤差を入れて「判定できない」を定量化。</a:t>
+              <a:t>NFW: シミュレーションで得られる暗黒物質ハローの典型的な密度の形。中心付近では距離に反比例、外側では距離の 3 乗に反比例して薄くなる。</a:t>
+            </a:r>
+          </a:p>
+          <a:p>
+            <a:r>
+              <a:t>形はエネルギーで変わらない (どのエネルギーでも同じ地図)。明るさ (倍率) だけを各エネルギーで決める。だから「どのエネルギーでハローが必要か」が有意度のスペクトルになる。</a:t>
+            </a:r>
+          </a:p>
+          <a:p>
+            <a:r>
+              <a:t>ICS と同じく、なめらかで中心に向かって明るい。違いは、ハローのほうが中心に強く集まっていること。</a:t>
+            </a:r>
+          </a:p>
+          <a:p>
+            <a:r>
+              <a:t>右の地図: 20.8 GeV の型紙 (倍率は掛けていない。形だけを見る図)。cloud_reports/2026-10-02_plot_templates.py で作成。</a:t>
             </a:r>
           </a:p>
         </p:txBody>
@@ -4128,7 +4314,7 @@
 </p:notes>
 </file>
 
-<file path=ppt/notesSlides/notesSlide49.xml><?xml version="1.0" encoding="utf-8"?>
+<file path=ppt/notesSlides/notesSlide7.xml><?xml version="1.0" encoding="utf-8"?>
 <p:notes xmlns:a="http://schemas.openxmlformats.org/drawingml/2006/main" xmlns:r="http://schemas.openxmlformats.org/officeDocument/2006/relationships" xmlns:p="http://schemas.openxmlformats.org/presentationml/2006/main">
   <p:cSld>
     <p:spTree>
@@ -4173,22 +4359,12 @@
           <a:lstStyle/>
           <a:p>
             <a:r>
-              <a:t>中村 (2017) 講究録 §2: 状態空間モデル。システムノイズ (シミュレーションの誤差) と観測ノイズ (観測の誤差) を分けて書く。</a:t>
-            </a:r>
-          </a:p>
-          <a:p>
-            <a:r>
-              <a:t>§2.3.3–2.3.4: アンサンブルカルマンフィルタ・粒子フィルタは、確率分布をたくさんのサンプル (アンサンブル) で近似する (式 11)。</a:t>
-            </a:r>
-          </a:p>
-          <a:p>
-            <a:r>
-              <a:t>§3.3: モデル化誤差と数値計算の誤差を、システムノイズとして統一的に扱えることがデータ同化の利点。</a:t>
-            </a:r>
-          </a:p>
-          <a:p>
-            <a:r>
-              <a:t>正直な位置づけ: この解析は講究録を読む前に行った。後から読んで、同じ発想だと分かった。データ同化の中心は時間とともに変わる現象で、1 枚の空の地図にそのまま使える手法ではない。</a:t>
+              <a:t>この後の尤度・有意度・MCMC のスライドは、全部「係数 9 個の決め方」の説明。難しい言葉が出てきたら、このスライドに戻って「今どの行の話か」を確認する。</a:t>
+            </a:r>
+          </a:p>
+          <a:p>
+            <a:r>
+              <a:t>型紙 = 前の 7 枚で見た地図。係数 = その地図を何倍して足すか。</a:t>
             </a:r>
           </a:p>
         </p:txBody>
@@ -4213,7 +4389,7 @@
 </p:notes>
 </file>
 
-<file path=ppt/notesSlides/notesSlide50.xml><?xml version="1.0" encoding="utf-8"?>
+<file path=ppt/notesSlides/notesSlide8.xml><?xml version="1.0" encoding="utf-8"?>
 <p:notes xmlns:a="http://schemas.openxmlformats.org/drawingml/2006/main" xmlns:r="http://schemas.openxmlformats.org/officeDocument/2006/relationships" xmlns:p="http://schemas.openxmlformats.org/presentationml/2006/main">
   <p:cSld>
     <p:spTree>
@@ -4257,7 +4433,29 @@
           <a:bodyPr/>
           <a:lstStyle/>
           <a:p>
-            <a:endParaRPr/>
+            <a:r>
+              <a:t>たとえ: 霧で何も見えない山の上で、一番高い場所を探したい。手元には高度計 (尤度) しかない。</a:t>
+            </a:r>
+          </a:p>
+          <a:p>
+            <a:r>
+              <a:t>歩く人 (MCMC) は、一歩ずつ足を出して高度計を見る。上りなら必ずその方向へ進み、下りでもたまに進む。下りにも進むのは、山頂で止まらずに山の広がり (どこまでが十分高いか) も知るため。</a:t>
+            </a:r>
+          </a:p>
+          <a:p>
+            <a:r>
+              <a:t>歩き終わったら、記録の中で一番高かった地点が最良の倍率、よく歩き回った範囲の幅が誤差になる。</a:t>
+            </a:r>
+          </a:p>
+          <a:p>
+            <a:r>
+              <a:t>ここでの「山」は 9 次元 (倍率が 9 個)。紙に描けないので、歩いて調べるしかない。</a:t>
+            </a:r>
+          </a:p>
+          <a:p>
+            <a:r>
+              <a:t>Totani (2025) §2.2: 最良値と統計誤差を、尤度を MCMC で最大化して求める。本研究も同じ (10/2 に揃えた)。</a:t>
+            </a:r>
           </a:p>
         </p:txBody>
       </p:sp>
@@ -4281,8 +4479,8 @@
 </p:notes>
 </file>
 
-<file path=ppt/notesSlides/notesSlide51.xml><?xml version="1.0" encoding="utf-8"?>
-<p:notes xmlns:a="http://schemas.openxmlformats.org/drawingml/2006/main" xmlns:p="http://schemas.openxmlformats.org/presentationml/2006/main" xmlns:r="http://schemas.openxmlformats.org/officeDocument/2006/relationships">
+<file path=ppt/notesSlides/notesSlide9.xml><?xml version="1.0" encoding="utf-8"?>
+<p:notes xmlns:a="http://schemas.openxmlformats.org/drawingml/2006/main" xmlns:r="http://schemas.openxmlformats.org/officeDocument/2006/relationships" xmlns:p="http://schemas.openxmlformats.org/presentationml/2006/main">
   <p:cSld>
     <p:spTree>
       <p:nvGrpSpPr>
@@ -4302,7 +4500,7 @@
         <p:nvSpPr>
           <p:cNvPr id="2" name="Slide Image Placeholder 1"/>
           <p:cNvSpPr>
-            <a:spLocks noGrp="1"/>
+            <a:spLocks noGrp="1" noRot="1" noChangeAspect="1"/>
           </p:cNvSpPr>
           <p:nvPr>
             <p:ph type="sldImg" idx="2"/>
@@ -4317,146 +4515,31 @@
             <a:spLocks noGrp="1"/>
           </p:cNvSpPr>
           <p:nvPr>
-            <p:ph type="body" idx="3" sz="quarter"/>
-          </p:nvPr>
-        </p:nvSpPr>
-        <p:spPr/>
-        <p:txBody>
-          <a:bodyPr/>
-          <a:lstStyle/>
-          <a:p>
-            <a:r>
-              <a:t>地図はどれも 20.8 GeV の型紙 (倍率は掛けていない。形だけを見る図)。Loop I は殻 1、バブルは正の型紙。</a:t>
-            </a:r>
-          </a:p>
-          <a:p>
-            <a:r>
-              <a:t>以下は、まとめる前の 6 枚のノート (詳しい説明)。</a:t>
-            </a:r>
-          </a:p>
-          <a:p>
-            <a:r>
-              <a:t>【① 等方背景】たとえ: 部屋の壁全体がぼんやり同じ明るさで光っている、その「底上げ」の明るさ。</a:t>
-            </a:r>
-          </a:p>
-          <a:p>
-            <a:r>
-              <a:t>最初の値 10⁻⁴ は、これまでに測られた「銀河の外から来るガンマ線の背景」の典型的な明るさ (Totani §2.3)。</a:t>
-            </a:r>
-          </a:p>
-          <a:p>
-            <a:r>
-              <a:t>Loop I との区別: 殻 1 は太陽が殻の壁の中にあるため空のほぼ全体を覆い、明るさの変化が等方背景と同じくらい平ら。データからは 2 つの分け方が決まらず、合計だけが決まる (.dev/TOTANI_SPEC.md 3.7a)。</a:t>
-            </a:r>
-          </a:p>
-          <a:p>
-            <a:r>
-              <a:t>右の地図: 20.8 GeV の型紙 (倍率は掛けていない。形だけを見る図)。cloud_reports/2026-10-02_plot_templates.py で作成。</a:t>
-            </a:r>
-          </a:p>
-          <a:p>
-            <a:r>
-              <a:t>【② ガス】GALPROP: 宇宙線が銀河の中でどう生まれ、どう広がるかを計算し、そこから出るガンマ線の地図を作るシミュレーション (ver. 54、設定 SLZ6R30T150C2。Fermi-LAT チームの銀河拡散モデルでも使われている設定)。</a:t>
-            </a:r>
-          </a:p>
-          <a:p>
-            <a:r>
-              <a:t>π⁰ は電気を持たない中間子で、できるとすぐ (10⁻¹⁶ 秒ほど) 光子 2 個に壊れる。</a:t>
-            </a:r>
-          </a:p>
-          <a:p>
-            <a:r>
-              <a:t>ガス雲の模様は、電波 (水素の 21 cm 線) や、ちりによる星の光の赤み (E(B−V)) から作ったガスの地図に由来する。</a:t>
-            </a:r>
-          </a:p>
-          <a:p>
-            <a:r>
-              <a:t>右の地図: 20.8 GeV の型紙 (倍率は掛けていない。形だけを見る図)。cloud_reports/2026-10-02_plot_templates.py で作成。</a:t>
-            </a:r>
-          </a:p>
-          <a:p>
-            <a:r>
-              <a:t>【③ ICS】逆コンプトン散乱: 普通のコンプトン散乱は光が電子をはね飛ばす。ここでは逆で、とても速い電子が、低いエネルギーの光にエネルギーを渡して、ガンマ線にする。</a:t>
-            </a:r>
-          </a:p>
-          <a:p>
-            <a:r>
-              <a:t>ガスの型紙と違って雲の模様が無く、なめらか。ハローもなめらかで中心に向かって明るいので、2 つの形が似ている (問題のスライドで説明する縮退)。</a:t>
-            </a:r>
-          </a:p>
-          <a:p>
-            <a:r>
-              <a:t>GALPROP の設定は IC_anisotropic = 0 (等方近似)。</a:t>
-            </a:r>
-          </a:p>
-          <a:p>
-            <a:r>
-              <a:t>右の地図: 20.8 GeV の型紙 (倍率は掛けていない。形だけを見る図)。cloud_reports/2026-10-02_plot_templates.py で作成。</a:t>
-            </a:r>
-          </a:p>
-          <a:p>
-            <a:r>
-              <a:t>【④ 点源】4FGL-DR4: Fermi-LAT の 14 年分のデータで見つかった天体のカタログ (gll_psc_v35.fit)。</a:t>
-            </a:r>
-          </a:p>
-          <a:p>
-            <a:r>
-              <a:t>PSF (点広がり関数): 望遠鏡で点を撮っても少しぼやけて写る、そのぼやけ方。エネルギーが低いほど大きくぼやける (1 GeV で約 0.85°、10 GeV で約 0.16°)。</a:t>
-            </a:r>
-          </a:p>
-          <a:p>
-            <a:r>
-              <a:t>拡張源: 大マゼラン雲や Cen A のローブのように、点ではなく広がって見える天体。Totani §2.3 と同じく、長半径の 2 倍の円を外す。</a:t>
-            </a:r>
-          </a:p>
-          <a:p>
-            <a:r>
-              <a:t>右の地図: 20.8 GeV の型紙 (倍率は掛けていない。形だけを見る図)。cloud_reports/2026-10-02_plot_templates.py で作成。</a:t>
-            </a:r>
-          </a:p>
-          <a:p>
-            <a:r>
-              <a:t>【⑤ Loop I】pc (パーセク) は距離の単位で、1 pc ≈ 3.26 光年。太陽から殻の中心までは 78 pc と 95 pc。</a:t>
-            </a:r>
-          </a:p>
-          <a:p>
-            <a:r>
-              <a:t>殻 1 は太陽が殻の壁の中にあるので、空のほぼ全体を覆う (左の地図)。そのため等方背景と区別しにくい。</a:t>
-            </a:r>
-          </a:p>
-          <a:p>
-            <a:r>
-              <a:t>超新星の残骸: 星が爆発したときに吹き飛んだガスが、泡のように広がったもの。</a:t>
-            </a:r>
-          </a:p>
-          <a:p>
-            <a:r>
-              <a:t>右の地図: 20.8 GeV の型紙 (倍率は掛けていない。形だけを見る図)。cloud_reports/2026-10-02_plot_templates.py で作成。</a:t>
-            </a:r>
-          </a:p>
-          <a:p>
-            <a:r>
-              <a:t>【⑥ フェルミバブル】なぜデータから作るか: バブルの正確な形を予言する理論が無いため。Totani は Fermi-LAT チームのやり方にならい、当てはめの残りから形を作った。</a:t>
-            </a:r>
-          </a:p>
-          <a:p>
-            <a:r>
-              <a:t>4.3 GeV の地図を使うのは、バブルがはっきり見えるため (Totani §3.1)。形はエネルギーで変えず、明るさ (倍率) だけを各エネルギーで決める。</a:t>
-            </a:r>
-          </a:p>
-          <a:p>
-            <a:r>
-              <a:t>負の型紙: 当てはめで光が余らなかった (予測が多すぎた) 場所。主に GALPROP の予測とデータのずれ。符号自由の倍率を掛けて補正に使う。</a:t>
-            </a:r>
-          </a:p>
-          <a:p>
-            <a:r>
-              <a:t>左の地図が正、右が負 (負の残差の大きさ)。</a:t>
-            </a:r>
-          </a:p>
-          <a:p>
-            <a:r>
-              <a:t>右の地図: 20.8 GeV の型紙 (倍率は掛けていない。形だけを見る図)。cloud_reports/2026-10-02_plot_templates.py で作成。</a:t>
+            <p:ph type="body" sz="quarter" idx="3"/>
+          </p:nvPr>
+        </p:nvSpPr>
+        <p:spPr/>
+        <p:txBody>
+          <a:bodyPr/>
+          <a:lstStyle/>
+          <a:p>
+            <a:r>
+              <a:t>「なし」は「あり」の特別な場合 (ハローの倍率 = 0) なので、入れ子のモデル。入れ子なら Δln L ≥ 0。</a:t>
+            </a:r>
+          </a:p>
+          <a:p>
+            <a:r>
+              <a:t>Wilks の定理: 帰無仮説 (ハローなし) が正しいとき、2Δln L は自由度 1 の χ² 分布。だから √(2Δln L) が「標準正規分布で何σ」に対応する。</a:t>
+            </a:r>
+          </a:p>
+          <a:p>
+            <a:r>
+              <a:t>定理の前提: データが多い (漸近的)、モデルが正しい、など。モデル (型紙) が間違っていると成り立たない。</a:t>
+            </a:r>
+          </a:p>
+          <a:p>
+            <a:r>
+              <a:t>Totani との関係: Totani (2025) Fig. 9 はハローあり・なしの ln L の差 (Δln L) を示しており、本文の 13–19σ はそれを σ = √(2Δln L) で σ に直した値。Totani は「Wilks の定理」という言葉は書いていないが、この換算はガンマ線天文学で標準 (2Δln L は TS = test statistic と呼ばれ、EGRET の解析 Mattox et al. 1996, ApJ 461, 396 から使われている)。本研究は Totani と同じ換算を使っている。</a:t>
             </a:r>
           </a:p>
         </p:txBody>
@@ -4468,73 +4551,7 @@
             <a:spLocks noGrp="1"/>
           </p:cNvSpPr>
           <p:nvPr>
-            <p:ph type="sldNum" idx="5" sz="quarter"/>
-          </p:nvPr>
-        </p:nvSpPr>
-        <p:spPr/>
-      </p:sp>
-    </p:spTree>
-  </p:cSld>
-  <p:clrMapOvr>
-    <a:masterClrMapping/>
-  </p:clrMapOvr>
-</p:notes>
-</file>
-
-<file path=ppt/notesSlides/notesSlide9.xml><?xml version="1.0" encoding="utf-8"?>
-<p:notes xmlns:a="http://schemas.openxmlformats.org/drawingml/2006/main" xmlns:p="http://schemas.openxmlformats.org/presentationml/2006/main" xmlns:r="http://schemas.openxmlformats.org/officeDocument/2006/relationships">
-  <p:cSld>
-    <p:spTree>
-      <p:nvGrpSpPr>
-        <p:cNvPr id="1" name=""/>
-        <p:cNvGrpSpPr/>
-        <p:nvPr/>
-      </p:nvGrpSpPr>
-      <p:grpSpPr>
-        <a:xfrm>
-          <a:off x="0" y="0"/>
-          <a:ext cx="0" cy="0"/>
-          <a:chOff x="0" y="0"/>
-          <a:chExt cx="0" cy="0"/>
-        </a:xfrm>
-      </p:grpSpPr>
-      <p:sp>
-        <p:nvSpPr>
-          <p:cNvPr id="2" name="Slide Image Placeholder 1"/>
-          <p:cNvSpPr>
-            <a:spLocks noGrp="1"/>
-          </p:cNvSpPr>
-          <p:nvPr>
-            <p:ph type="sldImg" idx="2"/>
-          </p:nvPr>
-        </p:nvSpPr>
-        <p:spPr/>
-      </p:sp>
-      <p:sp>
-        <p:nvSpPr>
-          <p:cNvPr id="3" name="Notes Placeholder 2"/>
-          <p:cNvSpPr>
-            <a:spLocks noGrp="1"/>
-          </p:cNvSpPr>
-          <p:nvPr>
-            <p:ph type="body" idx="3" sz="quarter"/>
-          </p:nvPr>
-        </p:nvSpPr>
-        <p:spPr/>
-        <p:txBody>
-          <a:bodyPr/>
-          <a:lstStyle/>
-          <a:p/>
-        </p:txBody>
-      </p:sp>
-      <p:sp>
-        <p:nvSpPr>
-          <p:cNvPr id="4" name="Slide Number Placeholder 3"/>
-          <p:cNvSpPr>
-            <a:spLocks noGrp="1"/>
-          </p:cNvSpPr>
-          <p:nvPr>
-            <p:ph type="sldNum" idx="5" sz="quarter"/>
+            <p:ph type="sldNum" sz="quarter" idx="5"/>
           </p:nvPr>
         </p:nvSpPr>
         <p:spPr/>
@@ -8133,6 +8150,36 @@
           </a:p>
         </p:txBody>
       </p:sp>
+      <p:pic>
+        <p:nvPicPr>
+          <p:cNvPr id="5" name="Picture 4" descr="The image displays a snippet of a Python function that calculates the log probability of a sequence of parameters given counts and a template dictionary, handling non-finite values by returning negative infinity.&#10;&#10;AI-generated content may be incorrect.">
+            <a:extLst>
+              <a:ext uri="{FF2B5EF4-FFF2-40B4-BE49-F238E27FC236}">
+                <a16:creationId xmlns:a16="http://schemas.microsoft.com/office/drawing/2014/main" id="{960CE5B3-4BC1-0B00-D670-CAC2F1397BD5}"/>
+              </a:ext>
+            </a:extLst>
+          </p:cNvPr>
+          <p:cNvPicPr>
+            <a:picLocks noChangeAspect="1"/>
+          </p:cNvPicPr>
+          <p:nvPr/>
+        </p:nvPicPr>
+        <p:blipFill>
+          <a:blip r:embed="rId3"/>
+          <a:stretch>
+            <a:fillRect/>
+          </a:stretch>
+        </p:blipFill>
+        <p:spPr>
+          <a:xfrm>
+            <a:off x="440692" y="5116782"/>
+            <a:ext cx="11310616" cy="1558973"/>
+          </a:xfrm>
+          <a:prstGeom prst="rect">
+            <a:avLst/>
+          </a:prstGeom>
+        </p:spPr>
+      </p:pic>
     </p:spTree>
   </p:cSld>
   <p:clrMapOvr>
@@ -9143,7 +9190,7 @@
           <p:nvPr/>
         </p:nvPicPr>
         <p:blipFill>
-          <a:blip r:embed="rId4"/>
+          <a:blip r:embed="rId3"/>
           <a:stretch>
             <a:fillRect/>
           </a:stretch>
@@ -9342,7 +9389,7 @@
           <p:nvPr/>
         </p:nvPicPr>
         <p:blipFill>
-          <a:blip r:embed="rId4"/>
+          <a:blip r:embed="rId3"/>
           <a:stretch>
             <a:fillRect/>
           </a:stretch>
@@ -13398,7 +13445,7 @@
 </file>
 
 <file path=ppt/slides/slide5.xml><?xml version="1.0" encoding="utf-8"?>
-<p:sld xmlns:a="http://schemas.openxmlformats.org/drawingml/2006/main" xmlns:p="http://schemas.openxmlformats.org/presentationml/2006/main" xmlns:r="http://schemas.openxmlformats.org/officeDocument/2006/relationships">
+<p:sld xmlns:a="http://schemas.openxmlformats.org/drawingml/2006/main" xmlns:r="http://schemas.openxmlformats.org/officeDocument/2006/relationships" xmlns:p="http://schemas.openxmlformats.org/presentationml/2006/main">
   <p:cSld>
     <p:spTree>
       <p:nvGrpSpPr>
@@ -13406,7 +13453,14 @@
         <p:cNvGrpSpPr/>
         <p:nvPr/>
       </p:nvGrpSpPr>
-      <p:grpSpPr/>
+      <p:grpSpPr>
+        <a:xfrm>
+          <a:off x="0" y="0"/>
+          <a:ext cx="0" cy="0"/>
+          <a:chOff x="0" y="0"/>
+          <a:chExt cx="0" cy="0"/>
+        </a:xfrm>
+      </p:grpSpPr>
       <p:sp>
         <p:nvSpPr>
           <p:cNvPr id="2" name="Title 1"/>
@@ -13438,7 +13492,7 @@
           <p:nvPr/>
         </p:nvPicPr>
         <p:blipFill>
-          <a:blip r:embed="rId2"/>
+          <a:blip r:embed="rId3"/>
           <a:stretch>
             <a:fillRect/>
           </a:stretch>
@@ -13497,7 +13551,7 @@
           <p:nvPr/>
         </p:nvPicPr>
         <p:blipFill>
-          <a:blip r:embed="rId3"/>
+          <a:blip r:embed="rId4"/>
           <a:stretch>
             <a:fillRect/>
           </a:stretch>
@@ -13556,7 +13610,7 @@
           <p:nvPr/>
         </p:nvPicPr>
         <p:blipFill>
-          <a:blip r:embed="rId4"/>
+          <a:blip r:embed="rId5"/>
           <a:stretch>
             <a:fillRect/>
           </a:stretch>
@@ -13615,7 +13669,7 @@
           <p:nvPr/>
         </p:nvPicPr>
         <p:blipFill>
-          <a:blip r:embed="rId5"/>
+          <a:blip r:embed="rId6"/>
           <a:stretch>
             <a:fillRect/>
           </a:stretch>
@@ -13674,7 +13728,7 @@
           <p:nvPr/>
         </p:nvPicPr>
         <p:blipFill>
-          <a:blip r:embed="rId6"/>
+          <a:blip r:embed="rId7"/>
           <a:stretch>
             <a:fillRect/>
           </a:stretch>
@@ -13733,7 +13787,7 @@
           <p:nvPr/>
         </p:nvPicPr>
         <p:blipFill>
-          <a:blip r:embed="rId7"/>
+          <a:blip r:embed="rId8"/>
           <a:stretch>
             <a:fillRect/>
           </a:stretch>

</xml_diff>

<commit_message>
slides: 本人の編集版を更新 (10-03 13:16)
</commit_message>
<xml_diff>
--- a/slides/2026-10-03_研究進捗報告_claude.pptx
+++ b/slides/2026-10-03_研究進捗報告_claude.pptx
@@ -184,7 +184,7 @@
   <pc:docChgLst>
     <pc:chgData name="202304239" userId="ab1adf7a-b8eb-4038-b404-de23e20d8a3a" providerId="ADAL" clId="{6C0E59ED-D716-49AF-B2FA-B94E7B8E5A8C}"/>
     <pc:docChg chg="custSel delSld modSld">
-      <pc:chgData name="202304239" userId="ab1adf7a-b8eb-4038-b404-de23e20d8a3a" providerId="ADAL" clId="{6C0E59ED-D716-49AF-B2FA-B94E7B8E5A8C}" dt="2026-10-03T04:13:39.011" v="59" actId="27614"/>
+      <pc:chgData name="202304239" userId="ab1adf7a-b8eb-4038-b404-de23e20d8a3a" providerId="ADAL" clId="{6C0E59ED-D716-49AF-B2FA-B94E7B8E5A8C}" dt="2026-10-03T04:15:36.651" v="66" actId="478"/>
       <pc:docMkLst>
         <pc:docMk/>
       </pc:docMkLst>
@@ -260,6 +260,37 @@
             <pc:docMk/>
             <pc:sldMk cId="0" sldId="295"/>
             <ac:picMk id="5" creationId="{960CE5B3-4BC1-0B00-D670-CAC2F1397BD5}"/>
+          </ac:picMkLst>
+        </pc:picChg>
+      </pc:sldChg>
+      <pc:sldChg chg="addSp delSp modSp mod">
+        <pc:chgData name="202304239" userId="ab1adf7a-b8eb-4038-b404-de23e20d8a3a" providerId="ADAL" clId="{6C0E59ED-D716-49AF-B2FA-B94E7B8E5A8C}" dt="2026-10-03T04:15:36.651" v="66" actId="478"/>
+        <pc:sldMkLst>
+          <pc:docMk/>
+          <pc:sldMk cId="0" sldId="296"/>
+        </pc:sldMkLst>
+        <pc:spChg chg="mod">
+          <ac:chgData name="202304239" userId="ab1adf7a-b8eb-4038-b404-de23e20d8a3a" providerId="ADAL" clId="{6C0E59ED-D716-49AF-B2FA-B94E7B8E5A8C}" dt="2026-10-03T04:15:29.193" v="64" actId="1076"/>
+          <ac:spMkLst>
+            <pc:docMk/>
+            <pc:sldMk cId="0" sldId="296"/>
+            <ac:spMk id="3" creationId="{00000000-0000-0000-0000-000000000000}"/>
+          </ac:spMkLst>
+        </pc:spChg>
+        <pc:spChg chg="del">
+          <ac:chgData name="202304239" userId="ab1adf7a-b8eb-4038-b404-de23e20d8a3a" providerId="ADAL" clId="{6C0E59ED-D716-49AF-B2FA-B94E7B8E5A8C}" dt="2026-10-03T04:15:36.651" v="66" actId="478"/>
+          <ac:spMkLst>
+            <pc:docMk/>
+            <pc:sldMk cId="0" sldId="296"/>
+            <ac:spMk id="8" creationId="{F85CD606-E3CE-F314-B3EE-F3D7028115CB}"/>
+          </ac:spMkLst>
+        </pc:spChg>
+        <pc:picChg chg="add mod">
+          <ac:chgData name="202304239" userId="ab1adf7a-b8eb-4038-b404-de23e20d8a3a" providerId="ADAL" clId="{6C0E59ED-D716-49AF-B2FA-B94E7B8E5A8C}" dt="2026-10-03T04:15:31.788" v="65" actId="1076"/>
+          <ac:picMkLst>
+            <pc:docMk/>
+            <pc:sldMk cId="0" sldId="296"/>
+            <ac:picMk id="5" creationId="{9F1A482B-9BF6-EF3C-C1F0-DE13BF60C225}"/>
           </ac:picMkLst>
         </pc:picChg>
       </pc:sldChg>
@@ -8239,7 +8270,7 @@
         </p:nvSpPr>
         <p:spPr>
           <a:xfrm>
-            <a:off x="548640" y="1371600"/>
+            <a:off x="0" y="1298772"/>
             <a:ext cx="5669280" cy="4297680"/>
           </a:xfrm>
         </p:spPr>
@@ -8312,46 +8343,36 @@
           </a:p>
         </p:txBody>
       </p:sp>
-      <p:sp>
-        <p:nvSpPr>
-          <p:cNvPr id="8" name="TextBox 7">
+      <p:pic>
+        <p:nvPicPr>
+          <p:cNvPr id="5" name="Picture 4" descr="The image contains a complex code snippet with comments detailing issues in a computational physics model, including negative values and unphysical results in a parameter space.&#10;&#10;AI-generated content may be incorrect.">
             <a:extLst>
               <a:ext uri="{FF2B5EF4-FFF2-40B4-BE49-F238E27FC236}">
-                <a16:creationId xmlns:a16="http://schemas.microsoft.com/office/drawing/2014/main" id="{F85CD606-E3CE-F314-B3EE-F3D7028115CB}"/>
+                <a16:creationId xmlns:a16="http://schemas.microsoft.com/office/drawing/2014/main" id="{9F1A482B-9BF6-EF3C-C1F0-DE13BF60C225}"/>
               </a:ext>
             </a:extLst>
           </p:cNvPr>
-          <p:cNvSpPr txBox="1"/>
+          <p:cNvPicPr>
+            <a:picLocks noChangeAspect="1"/>
+          </p:cNvPicPr>
           <p:nvPr/>
-        </p:nvSpPr>
+        </p:nvPicPr>
+        <p:blipFill>
+          <a:blip r:embed="rId3"/>
+          <a:stretch>
+            <a:fillRect/>
+          </a:stretch>
+        </p:blipFill>
         <p:spPr>
           <a:xfrm>
-            <a:off x="5837182" y="5663239"/>
-            <a:ext cx="6093372" cy="923330"/>
+            <a:off x="5775158" y="1210540"/>
+            <a:ext cx="6477561" cy="2796782"/>
           </a:xfrm>
           <a:prstGeom prst="rect">
             <a:avLst/>
           </a:prstGeom>
-          <a:noFill/>
         </p:spPr>
-        <p:txBody>
-          <a:bodyPr wrap="square">
-            <a:spAutoFit/>
-          </a:bodyPr>
-          <a:lstStyle/>
-          <a:p>
-            <a:r>
-              <a:rPr lang="en-US" sz="1400" b="1"/>
-              <a:t>Reference:</a:t>
-            </a:r>
-            <a:r>
-              <a:rPr lang="en-US" sz="1400"/>
-              <a:t> D. Foreman-Mackey et al. (2013), PASP 125, 306</a:t>
-            </a:r>
-            <a:endParaRPr lang="en-US"/>
-          </a:p>
-        </p:txBody>
-      </p:sp>
+      </p:pic>
     </p:spTree>
   </p:cSld>
   <p:clrMapOvr>

</xml_diff>

<commit_message>
slides: 本人の編集版を更新 (10-03 13:17)
</commit_message>
<xml_diff>
--- a/slides/2026-10-03_研究進捗報告_claude.pptx
+++ b/slides/2026-10-03_研究進捗報告_claude.pptx
@@ -184,7 +184,7 @@
   <pc:docChgLst>
     <pc:chgData name="202304239" userId="ab1adf7a-b8eb-4038-b404-de23e20d8a3a" providerId="ADAL" clId="{6C0E59ED-D716-49AF-B2FA-B94E7B8E5A8C}"/>
     <pc:docChg chg="custSel delSld modSld">
-      <pc:chgData name="202304239" userId="ab1adf7a-b8eb-4038-b404-de23e20d8a3a" providerId="ADAL" clId="{6C0E59ED-D716-49AF-B2FA-B94E7B8E5A8C}" dt="2026-10-03T04:15:36.651" v="66" actId="478"/>
+      <pc:chgData name="202304239" userId="ab1adf7a-b8eb-4038-b404-de23e20d8a3a" providerId="ADAL" clId="{6C0E59ED-D716-49AF-B2FA-B94E7B8E5A8C}" dt="2026-10-03T04:16:37.708" v="74" actId="14100"/>
       <pc:docMkLst>
         <pc:docMk/>
       </pc:docMkLst>
@@ -264,13 +264,13 @@
         </pc:picChg>
       </pc:sldChg>
       <pc:sldChg chg="addSp delSp modSp mod">
-        <pc:chgData name="202304239" userId="ab1adf7a-b8eb-4038-b404-de23e20d8a3a" providerId="ADAL" clId="{6C0E59ED-D716-49AF-B2FA-B94E7B8E5A8C}" dt="2026-10-03T04:15:36.651" v="66" actId="478"/>
+        <pc:chgData name="202304239" userId="ab1adf7a-b8eb-4038-b404-de23e20d8a3a" providerId="ADAL" clId="{6C0E59ED-D716-49AF-B2FA-B94E7B8E5A8C}" dt="2026-10-03T04:16:37.708" v="74" actId="14100"/>
         <pc:sldMkLst>
           <pc:docMk/>
           <pc:sldMk cId="0" sldId="296"/>
         </pc:sldMkLst>
         <pc:spChg chg="mod">
-          <ac:chgData name="202304239" userId="ab1adf7a-b8eb-4038-b404-de23e20d8a3a" providerId="ADAL" clId="{6C0E59ED-D716-49AF-B2FA-B94E7B8E5A8C}" dt="2026-10-03T04:15:29.193" v="64" actId="1076"/>
+          <ac:chgData name="202304239" userId="ab1adf7a-b8eb-4038-b404-de23e20d8a3a" providerId="ADAL" clId="{6C0E59ED-D716-49AF-B2FA-B94E7B8E5A8C}" dt="2026-10-03T04:16:37.708" v="74" actId="14100"/>
           <ac:spMkLst>
             <pc:docMk/>
             <pc:sldMk cId="0" sldId="296"/>
@@ -285,12 +285,20 @@
             <ac:spMk id="8" creationId="{F85CD606-E3CE-F314-B3EE-F3D7028115CB}"/>
           </ac:spMkLst>
         </pc:spChg>
-        <pc:picChg chg="add mod">
-          <ac:chgData name="202304239" userId="ab1adf7a-b8eb-4038-b404-de23e20d8a3a" providerId="ADAL" clId="{6C0E59ED-D716-49AF-B2FA-B94E7B8E5A8C}" dt="2026-10-03T04:15:31.788" v="65" actId="1076"/>
+        <pc:picChg chg="add del mod">
+          <ac:chgData name="202304239" userId="ab1adf7a-b8eb-4038-b404-de23e20d8a3a" providerId="ADAL" clId="{6C0E59ED-D716-49AF-B2FA-B94E7B8E5A8C}" dt="2026-10-03T04:16:25.221" v="69" actId="478"/>
           <ac:picMkLst>
             <pc:docMk/>
             <pc:sldMk cId="0" sldId="296"/>
             <ac:picMk id="5" creationId="{9F1A482B-9BF6-EF3C-C1F0-DE13BF60C225}"/>
+          </ac:picMkLst>
+        </pc:picChg>
+        <pc:picChg chg="add mod">
+          <ac:chgData name="202304239" userId="ab1adf7a-b8eb-4038-b404-de23e20d8a3a" providerId="ADAL" clId="{6C0E59ED-D716-49AF-B2FA-B94E7B8E5A8C}" dt="2026-10-03T04:16:30.783" v="72" actId="1076"/>
+          <ac:picMkLst>
+            <pc:docMk/>
+            <pc:sldMk cId="0" sldId="296"/>
+            <ac:picMk id="7" creationId="{DBE7D927-8B33-8CDB-1BC3-DBD46AE4DF3A}"/>
           </ac:picMkLst>
         </pc:picChg>
       </pc:sldChg>
@@ -8270,8 +8278,8 @@
         </p:nvSpPr>
         <p:spPr>
           <a:xfrm>
-            <a:off x="0" y="1298772"/>
-            <a:ext cx="5669280" cy="4297680"/>
+            <a:off x="0" y="1298771"/>
+            <a:ext cx="4652211" cy="4572639"/>
           </a:xfrm>
         </p:spPr>
         <p:txBody>
@@ -8345,10 +8353,10 @@
       </p:sp>
       <p:pic>
         <p:nvPicPr>
-          <p:cNvPr id="5" name="Picture 4" descr="The image contains a complex code snippet with comments detailing issues in a computational physics model, including negative values and unphysical results in a parameter space.&#10;&#10;AI-generated content may be incorrect.">
+          <p:cNvPr id="7" name="Picture 6" descr="The image depicts a segment of Python code, including function definitions and a conditional statement, related to data analysis or scientific computation.&#10;&#10;AI-generated content may be incorrect.">
             <a:extLst>
               <a:ext uri="{FF2B5EF4-FFF2-40B4-BE49-F238E27FC236}">
-                <a16:creationId xmlns:a16="http://schemas.microsoft.com/office/drawing/2014/main" id="{9F1A482B-9BF6-EF3C-C1F0-DE13BF60C225}"/>
+                <a16:creationId xmlns:a16="http://schemas.microsoft.com/office/drawing/2014/main" id="{DBE7D927-8B33-8CDB-1BC3-DBD46AE4DF3A}"/>
               </a:ext>
             </a:extLst>
           </p:cNvPr>
@@ -8365,8 +8373,8 @@
         </p:blipFill>
         <p:spPr>
           <a:xfrm>
-            <a:off x="5775158" y="1210540"/>
-            <a:ext cx="6477561" cy="2796782"/>
+            <a:off x="4830442" y="1298772"/>
+            <a:ext cx="7361558" cy="3848433"/>
           </a:xfrm>
           <a:prstGeom prst="rect">
             <a:avLst/>

</xml_diff>

<commit_message>
slides: 本人の編集版を更新 (10-03 13:51)
</commit_message>
<xml_diff>
--- a/slides/2026-10-03_研究進捗報告_claude.pptx
+++ b/slides/2026-10-03_研究進捗報告_claude.pptx
@@ -1489,6 +1489,16 @@
           <a:lstStyle/>
           <a:p>
             <a:r>
+              <a:t>【Totani の 13〜19σ とは】論文 §3.2 の「13–19σ」は、ハローの形を 3 通り (NFW-ρ^2.5・ρ²・ρ¹) で当てはめたときの幅。誤差の幅でも、何も無い空での較正でもない (論文にその確認は無い)。</a:t>
+            </a:r>
+          </a:p>
+          <a:p>
+            <a:r>
+              <a:t>同じ定義 (ln L の差 → σ) で Fig. 9 から読むと、21 GeV で ρ² が約 14.3σ、ρ^2.5 が約 13.6σ、ρ¹ が約 12.1σ。赤の線は ρ² の値。13–19σ の 19 がどう計算されたかは論文に書かれていない。</a:t>
+            </a:r>
+          </a:p>
+          <a:p>
+            <a:r>
               <a:t>青が本研究 (10/3、本人 PC で Totani と同じやり方 = MCMC で最良値。results/mcmc_allbins_gasICS_v20t/)、赤が Totani Fig. 9。</a:t>
             </a:r>
           </a:p>
@@ -2175,6 +2185,21 @@
           <a:lstStyle/>
           <a:p>
             <a:r>
+              <a:t>【電球のたとえ】電球が 1 個も無い真っ暗な部屋 (何も無い空) を 23 部屋用意して、天の川と同じ明るさ計 (解析) で「豆電球ある？」と測る。本当に何も無ければ、針は 0 のまわりで ±1 くらい揺れるはず (理論)。実際には ±1.26 くらい揺れた。→ この明るさ計は、揺れを 1.26 倍大きく見せるクセがある。だから天の川の 19.0 も 1.26 で割って、約 15 と読み直す。</a:t>
+            </a:r>
+          </a:p>
+          <a:p>
+            <a:r>
+              <a:t>【本当に何も無い所？】既知の天体 (矮小銀河など) から離して、|b| &gt; 20° で選んだ。ただし、見えないほど暗い天体や、背景の型紙の小さな誤りは残る。それも含めて「何も無いはずの所でもこれだけ揺れる」を測るのが目的。</a:t>
+            </a:r>
+          </a:p>
+          <a:p>
+            <a:r>
+              <a:t>【1.26 の出し方】23 か所 × ビン 2〜10 (9 本) = 207 個の σ を、それぞれ 2 乗して平均し、平方根をとった値 (RMS)。中央値ではない。理論どおりなら 1。</a:t>
+            </a:r>
+          </a:p>
+          <a:p>
+            <a:r>
               <a:t>ばらつき = 0 からのずれの 2 乗平均の平方根。光子が十分あるビン 2–10 (2.6–169 GeV) の 207 個から計算。</a:t>
             </a:r>
           </a:p>
@@ -2260,6 +2285,11 @@
           <a:lstStyle/>
           <a:p>
             <a:r>
+              <a:t>【図の読み方】横 = エネルギー、縦 = 23 部屋で測った針の揺れの大きさ。黒い点 1 つ = そのエネルギーだけで、23 個の σ から出した揺れ。点線 1 = 理論どおりの揺れ。黒い点はどれも 1 より上 (1.1〜1.4)。灰色の帯 = 黒い点のエネルギー (ビン 2〜10) の 207 個をまとめて出した 1.26 (中央値ではなく、全部まとめた RMS)。灰色の点 (一番低いエネルギーと 285 GeV 以上) は、ぼやけが大きい・光子が少ないので、まとめる計算から外した。</a:t>
+            </a:r>
+          </a:p>
+          <a:p>
+            <a:r>
               <a:t>黒の点: 各エネルギービンで 23 か所から測ったばらつきと 95% 区間。灰色の帯: ビン 2–10 をまとめた値 1.26 とその 95% 区間。</a:t>
             </a:r>
           </a:p>
@@ -2490,6 +2520,21 @@
           <a:lstStyle/>
           <a:p>
             <a:r>
+              <a:t>【電球のたとえ】暗黒物質のハロー = 電球。J ファクター = 「その方向に、電球がどれだけ明るく見えるはずか」の目安。対消滅は粒子 2 つがぶつかって起きるので、暗黒物質が 2 倍濃いと 4 倍明るい (密度の 2 乗)。それを視線に沿って全部足したのが J。</a:t>
+            </a:r>
+          </a:p>
+          <a:p>
+            <a:r>
+              <a:t>天の川の電球の明るさは、もう測れている (19σ の超過)。電球の種類 (粒子) は同じなので、「J が天の川の何倍か」さえ分かれば、矮小銀河の電球がどれだけ明るく見えるはずかが計算できる。たとえ: 同じ種類の電球なら、自分の部屋の電球の明るさから、遠くの家の窓の明るさを、電球の数と距離の比だけで予想できる。</a:t>
+            </a:r>
+          </a:p>
+          <a:p>
+            <a:r>
+              <a:t>矮小銀河の J は星の動きから推定する。星が速く動き回っている銀河ほど重い (暗黒物質が多い)。だから J は星の速度のばらつき σ_los の 4 乗に比例する。</a:t>
+            </a:r>
+          </a:p>
+          <a:p>
+            <a:r>
               <a:t>⟨σv⟩: 対消滅の起きやすさ、m: 粒子の質量、dN/dE: 1 回の対消滅で出る光のスペクトル。天の川と矮小銀河で同じエネルギービンを見るので、これらは全部共通。</a:t>
             </a:r>
           </a:p>
@@ -2650,6 +2695,21 @@
           <a:lstStyle/>
           <a:p>
             <a:r>
+              <a:t>【何をしているか】1 個の話ではない。矮小銀河 52 個と M31・M33 を、1 個ずつ天の川と同じ解析にかけ、出てきた σ (54 天体 × 13 ビン = 702 個) をヒストグラムにした。灰色は何も無い空 23 か所。</a:t>
+            </a:r>
+          </a:p>
+          <a:p>
+            <a:r>
+              <a:t>【電球のたとえ】遠くの家 54 軒の窓を 1 軒ずつ明るさ計で測り、「真っ暗な部屋で測った針の揺れ」と並べた。2 つの形がほぼ同じ → どの窓も、真っ暗な部屋と区別がつかない。</a:t>
+            </a:r>
+          </a:p>
+          <a:p>
+            <a:r>
+              <a:t>ただし「暗黒物質は無い」とは言えない。そもそも 1 軒ずつでは暗すぎて、あっても見えない明るさだから (次のスライド)。</a:t>
+            </a:r>
+          </a:p>
+          <a:p>
+            <a:r>
               <a:t>黒: 矮小銀河 52 + M31・M33 の全 13 ビンの有意度 (702 個)。灰色: 何も無い空 23 か所 (299 個)。点線: 理論の分布。</a:t>
             </a:r>
           </a:p>
@@ -2733,6 +2793,16 @@
         <p:txBody>
           <a:bodyPr/>
           <a:lstStyle/>
+          <a:p>
+            <a:r>
+              <a:t>【電球のたとえ】1 軒ずつでは暗すぎるので、43 軒の結果を足し合わせて 1 つの数 T にする。明るく見えるはずの家 (J が大きい) ほど重く数える。z_i = 家 i で測った針の値、w_i = 家 i に期待される明るさ。</a:t>
+            </a:r>
+          </a:p>
+          <a:p>
+            <a:r>
+              <a:t>暗黒物質があれば T は平均 1.77 くらい。無ければ 0 のまわり ±1。実測は 0.39。期待の 1.77 から 1.4σ 下にずれている → 「無い」寄りだが、決めつけるほど離れていない。</a:t>
+            </a:r>
+          </a:p>
           <a:p>
             <a:r>
               <a:t>予測が大きい天体ほど重く数える重み付き和。予測のパターンが分かっているときに、いちばん検出しやすいまとめ方。</a:t>

</xml_diff>

<commit_message>
slides: 本人の編集版を更新 (10-03 15:09)
</commit_message>
<xml_diff>
--- a/slides/2026-10-03_研究進捗報告_claude.pptx
+++ b/slides/2026-10-03_研究進捗報告_claude.pptx
@@ -184,7 +184,7 @@
   <pc:docChgLst>
     <pc:chgData name="202304239" userId="ab1adf7a-b8eb-4038-b404-de23e20d8a3a" providerId="ADAL" clId="{6C0E59ED-D716-49AF-B2FA-B94E7B8E5A8C}"/>
     <pc:docChg chg="custSel delSld modSld">
-      <pc:chgData name="202304239" userId="ab1adf7a-b8eb-4038-b404-de23e20d8a3a" providerId="ADAL" clId="{6C0E59ED-D716-49AF-B2FA-B94E7B8E5A8C}" dt="2026-10-03T04:16:37.708" v="74" actId="14100"/>
+      <pc:chgData name="202304239" userId="ab1adf7a-b8eb-4038-b404-de23e20d8a3a" providerId="ADAL" clId="{6C0E59ED-D716-49AF-B2FA-B94E7B8E5A8C}" dt="2026-10-03T06:08:02.273" v="75" actId="22"/>
       <pc:docMkLst>
         <pc:docMk/>
       </pc:docMkLst>
@@ -299,6 +299,21 @@
             <pc:docMk/>
             <pc:sldMk cId="0" sldId="296"/>
             <ac:picMk id="7" creationId="{DBE7D927-8B33-8CDB-1BC3-DBD46AE4DF3A}"/>
+          </ac:picMkLst>
+        </pc:picChg>
+      </pc:sldChg>
+      <pc:sldChg chg="addSp mod">
+        <pc:chgData name="202304239" userId="ab1adf7a-b8eb-4038-b404-de23e20d8a3a" providerId="ADAL" clId="{6C0E59ED-D716-49AF-B2FA-B94E7B8E5A8C}" dt="2026-10-03T06:08:02.273" v="75" actId="22"/>
+        <pc:sldMkLst>
+          <pc:docMk/>
+          <pc:sldMk cId="0" sldId="297"/>
+        </pc:sldMkLst>
+        <pc:picChg chg="add">
+          <ac:chgData name="202304239" userId="ab1adf7a-b8eb-4038-b404-de23e20d8a3a" providerId="ADAL" clId="{6C0E59ED-D716-49AF-B2FA-B94E7B8E5A8C}" dt="2026-10-03T06:08:02.273" v="75" actId="22"/>
+          <ac:picMkLst>
+            <pc:docMk/>
+            <pc:sldMk cId="0" sldId="297"/>
+            <ac:picMk id="5" creationId="{A90FDE7D-1E04-5388-2EF9-2BF6180BCFE4}"/>
           </ac:picMkLst>
         </pc:picChg>
       </pc:sldChg>
@@ -8622,6 +8637,36 @@
           </a:p>
         </p:txBody>
       </p:sp>
+      <p:pic>
+        <p:nvPicPr>
+          <p:cNvPr id="5" name="Picture 4">
+            <a:extLst>
+              <a:ext uri="{FF2B5EF4-FFF2-40B4-BE49-F238E27FC236}">
+                <a16:creationId xmlns:a16="http://schemas.microsoft.com/office/drawing/2014/main" id="{A90FDE7D-1E04-5388-2EF9-2BF6180BCFE4}"/>
+              </a:ext>
+            </a:extLst>
+          </p:cNvPr>
+          <p:cNvPicPr>
+            <a:picLocks noChangeAspect="1"/>
+          </p:cNvPicPr>
+          <p:nvPr/>
+        </p:nvPicPr>
+        <p:blipFill>
+          <a:blip r:embed="rId3"/>
+          <a:stretch>
+            <a:fillRect/>
+          </a:stretch>
+        </p:blipFill>
+        <p:spPr>
+          <a:xfrm>
+            <a:off x="3988887" y="2724089"/>
+            <a:ext cx="4214225" cy="1409822"/>
+          </a:xfrm>
+          <a:prstGeom prst="rect">
+            <a:avLst/>
+          </a:prstGeom>
+        </p:spPr>
+      </p:pic>
     </p:spTree>
   </p:cSld>
   <p:clrMapOvr>

</xml_diff>

<commit_message>
slides: 本人の編集版を更新 (10-03 15:10)
</commit_message>
<xml_diff>
--- a/slides/2026-10-03_研究進捗報告_claude.pptx
+++ b/slides/2026-10-03_研究進捗報告_claude.pptx
@@ -184,7 +184,7 @@
   <pc:docChgLst>
     <pc:chgData name="202304239" userId="ab1adf7a-b8eb-4038-b404-de23e20d8a3a" providerId="ADAL" clId="{6C0E59ED-D716-49AF-B2FA-B94E7B8E5A8C}"/>
     <pc:docChg chg="custSel delSld modSld">
-      <pc:chgData name="202304239" userId="ab1adf7a-b8eb-4038-b404-de23e20d8a3a" providerId="ADAL" clId="{6C0E59ED-D716-49AF-B2FA-B94E7B8E5A8C}" dt="2026-10-03T06:08:02.273" v="75" actId="22"/>
+      <pc:chgData name="202304239" userId="ab1adf7a-b8eb-4038-b404-de23e20d8a3a" providerId="ADAL" clId="{6C0E59ED-D716-49AF-B2FA-B94E7B8E5A8C}" dt="2026-10-03T06:10:09.262" v="81" actId="478"/>
       <pc:docMkLst>
         <pc:docMk/>
       </pc:docMkLst>
@@ -314,6 +314,36 @@
             <pc:docMk/>
             <pc:sldMk cId="0" sldId="297"/>
             <ac:picMk id="5" creationId="{A90FDE7D-1E04-5388-2EF9-2BF6180BCFE4}"/>
+          </ac:picMkLst>
+        </pc:picChg>
+      </pc:sldChg>
+      <pc:sldChg chg="addSp modSp mod">
+        <pc:chgData name="202304239" userId="ab1adf7a-b8eb-4038-b404-de23e20d8a3a" providerId="ADAL" clId="{6C0E59ED-D716-49AF-B2FA-B94E7B8E5A8C}" dt="2026-10-03T06:10:08.014" v="80" actId="27614"/>
+        <pc:sldMkLst>
+          <pc:docMk/>
+          <pc:sldMk cId="0" sldId="299"/>
+        </pc:sldMkLst>
+        <pc:picChg chg="add mod">
+          <ac:chgData name="202304239" userId="ab1adf7a-b8eb-4038-b404-de23e20d8a3a" providerId="ADAL" clId="{6C0E59ED-D716-49AF-B2FA-B94E7B8E5A8C}" dt="2026-10-03T06:10:08.014" v="80" actId="27614"/>
+          <ac:picMkLst>
+            <pc:docMk/>
+            <pc:sldMk cId="0" sldId="299"/>
+            <ac:picMk id="5" creationId="{4380DBC0-9AA7-8727-D6C3-C05AE0BF39C9}"/>
+          </ac:picMkLst>
+        </pc:picChg>
+      </pc:sldChg>
+      <pc:sldChg chg="addSp delSp modSp mod">
+        <pc:chgData name="202304239" userId="ab1adf7a-b8eb-4038-b404-de23e20d8a3a" providerId="ADAL" clId="{6C0E59ED-D716-49AF-B2FA-B94E7B8E5A8C}" dt="2026-10-03T06:10:09.262" v="81" actId="478"/>
+        <pc:sldMkLst>
+          <pc:docMk/>
+          <pc:sldMk cId="0" sldId="300"/>
+        </pc:sldMkLst>
+        <pc:picChg chg="add del mod">
+          <ac:chgData name="202304239" userId="ab1adf7a-b8eb-4038-b404-de23e20d8a3a" providerId="ADAL" clId="{6C0E59ED-D716-49AF-B2FA-B94E7B8E5A8C}" dt="2026-10-03T06:10:09.262" v="81" actId="478"/>
+          <ac:picMkLst>
+            <pc:docMk/>
+            <pc:sldMk cId="0" sldId="300"/>
+            <ac:picMk id="5" creationId="{4206F3F6-6980-B027-0044-AE735E407525}"/>
           </ac:picMkLst>
         </pc:picChg>
       </pc:sldChg>
@@ -9104,6 +9134,36 @@
           </a:p>
         </p:txBody>
       </p:sp>
+      <p:pic>
+        <p:nvPicPr>
+          <p:cNvPr id="5" name="Picture 4" descr="The image shows a segment of Python code with numpy array operations, initializing a position array for a simulation or optimization process, adjusting the position values with small random perturbations, and selectively modifying the sign of certain elements.&#10;&#10;AI-generated content may be incorrect.">
+            <a:extLst>
+              <a:ext uri="{FF2B5EF4-FFF2-40B4-BE49-F238E27FC236}">
+                <a16:creationId xmlns:a16="http://schemas.microsoft.com/office/drawing/2014/main" id="{4380DBC0-9AA7-8727-D6C3-C05AE0BF39C9}"/>
+              </a:ext>
+            </a:extLst>
+          </p:cNvPr>
+          <p:cNvPicPr>
+            <a:picLocks noChangeAspect="1"/>
+          </p:cNvPicPr>
+          <p:nvPr/>
+        </p:nvPicPr>
+        <p:blipFill>
+          <a:blip r:embed="rId3"/>
+          <a:stretch>
+            <a:fillRect/>
+          </a:stretch>
+        </p:blipFill>
+        <p:spPr>
+          <a:xfrm>
+            <a:off x="5120027" y="454311"/>
+            <a:ext cx="7071973" cy="1005927"/>
+          </a:xfrm>
+          <a:prstGeom prst="rect">
+            <a:avLst/>
+          </a:prstGeom>
+        </p:spPr>
+      </p:pic>
     </p:spTree>
   </p:cSld>
   <p:clrMapOvr>

</xml_diff>